<commit_message>
Publicare 2026-10-06 (versiuni: 2026.1.0, 2026.1.1)
</commit_message>
<xml_diff>
--- a/OPT_DETECTIVI/ro/fisiere/C01.pptx
+++ b/OPT_DETECTIVI/ro/fisiere/C01.pptx
@@ -3062,7 +3062,9 @@
           <a:bodyPr/>
           <a:lstStyle/>
           <a:p>
-            <a:endParaRPr lang="en-US" dirty="0"/>
+            <a:r>
+              <a:t>Lucrarea lui Snow a fost retipărită în 1936, cu o introducere a lui Wade Hampton Frost.</a:t>
+            </a:r>
           </a:p>
         </p:txBody>
       </p:sp>
@@ -3735,7 +3737,7 @@
           <a:lstStyle/>
           <a:p>
             <a:r>
-              <a:t>Lista de evaluare este cea de zece etape de pe acest diapozitiv, în ordinea lor logică. La evaluarea finală se cer cel puțin opt dintre ele, aplicate pe cazul simulat din quiz-ul final (fișa, criteriul 10.8).</a:t>
+              <a:t>Etapele nu se cer după număr. Chestionarul de 15 grile din ultima ședință poate întreba ordinea lor logică, cu definiția de caz înaintea căutării cazurilor.</a:t>
             </a:r>
           </a:p>
         </p:txBody>
@@ -4744,7 +4746,9 @@
           <a:bodyPr/>
           <a:lstStyle/>
           <a:p>
-            <a:endParaRPr lang="en-US" dirty="0"/>
+            <a:r>
+              <a:t>La prima întrebare, nu se poate da un an: acceptarea largă a lucrării lui Snow a cerut o schimbare majoră a felului în care erau gândite cauzele bolilor.</a:t>
+            </a:r>
           </a:p>
         </p:txBody>
       </p:sp>
@@ -6180,7 +6184,7 @@
                 <a:ea typeface="Palatino Linotype" pitchFamily="34" charset="-122"/>
                 <a:cs typeface="Palatino Linotype" pitchFamily="34" charset="-120"/>
               </a:rPr>
-              <a:t>Nu una, ci patru explicații compatibile cu datele:</a:t>
+              <a:t>Nu una, ci cel puțin trei explicații compatibile cu datele:</a:t>
             </a:r>
             <a:endParaRPr lang="en-US" sz="1300" dirty="0"/>
           </a:p>
@@ -6194,7 +6198,7 @@
         </p:nvSpPr>
         <p:spPr>
           <a:xfrm>
-            <a:off x="594360" y="4800600"/>
+            <a:off x="1988820" y="4800600"/>
             <a:ext cx="2606040" cy="914400"/>
           </a:xfrm>
           <a:prstGeom prst="roundRect">
@@ -6228,7 +6232,7 @@
         </p:nvSpPr>
         <p:spPr>
           <a:xfrm>
-            <a:off x="777240" y="4892040"/>
+            <a:off x="2171700" y="4892040"/>
             <a:ext cx="2240280" cy="502920"/>
           </a:xfrm>
           <a:prstGeom prst="rect">
@@ -6267,7 +6271,7 @@
         </p:nvSpPr>
         <p:spPr>
           <a:xfrm>
-            <a:off x="777240" y="5376672"/>
+            <a:off x="2171700" y="5376672"/>
             <a:ext cx="2240280" cy="274320"/>
           </a:xfrm>
           <a:prstGeom prst="rect">
@@ -6306,7 +6310,7 @@
         </p:nvSpPr>
         <p:spPr>
           <a:xfrm>
-            <a:off x="3383280" y="4800600"/>
+            <a:off x="4777740" y="4800600"/>
             <a:ext cx="2606040" cy="914400"/>
           </a:xfrm>
           <a:prstGeom prst="roundRect">
@@ -6340,7 +6344,7 @@
         </p:nvSpPr>
         <p:spPr>
           <a:xfrm>
-            <a:off x="3566160" y="4892040"/>
+            <a:off x="4960620" y="4892040"/>
             <a:ext cx="2240280" cy="502920"/>
           </a:xfrm>
           <a:prstGeom prst="rect">
@@ -6379,7 +6383,7 @@
         </p:nvSpPr>
         <p:spPr>
           <a:xfrm>
-            <a:off x="3566160" y="5376672"/>
+            <a:off x="4960620" y="5376672"/>
             <a:ext cx="2240280" cy="274320"/>
           </a:xfrm>
           <a:prstGeom prst="rect">
@@ -6418,7 +6422,7 @@
         </p:nvSpPr>
         <p:spPr>
           <a:xfrm>
-            <a:off x="6172200" y="4800600"/>
+            <a:off x="7566660" y="4800600"/>
             <a:ext cx="2606040" cy="914400"/>
           </a:xfrm>
           <a:prstGeom prst="roundRect">
@@ -6452,7 +6456,7 @@
         </p:nvSpPr>
         <p:spPr>
           <a:xfrm>
-            <a:off x="6355080" y="4892040"/>
+            <a:off x="7749540" y="4892040"/>
             <a:ext cx="2240280" cy="502920"/>
           </a:xfrm>
           <a:prstGeom prst="rect">
@@ -6491,7 +6495,7 @@
         </p:nvSpPr>
         <p:spPr>
           <a:xfrm>
-            <a:off x="6355080" y="5376672"/>
+            <a:off x="7749540" y="5376672"/>
             <a:ext cx="2240280" cy="274320"/>
           </a:xfrm>
           <a:prstGeom prst="rect">
@@ -6517,118 +6521,6 @@
                 <a:cs typeface="Palatino Linotype" pitchFamily="34" charset="-120"/>
               </a:rPr>
               <a:t>Snow, p. 51; Whitehead, p. 162</a:t>
-            </a:r>
-            <a:endParaRPr lang="en-US" sz="1000" dirty="0"/>
-          </a:p>
-        </p:txBody>
-      </p:sp>
-      <p:sp>
-        <p:nvSpPr>
-          <p:cNvPr id="19" name="Shape 17"/>
-          <p:cNvSpPr/>
-          <p:nvPr/>
-        </p:nvSpPr>
-        <p:spPr>
-          <a:xfrm>
-            <a:off x="8961120" y="4800600"/>
-            <a:ext cx="2606040" cy="914400"/>
-          </a:xfrm>
-          <a:prstGeom prst="roundRect">
-            <a:avLst>
-              <a:gd name="adj" fmla="val 9000"/>
-            </a:avLst>
-          </a:prstGeom>
-          <a:solidFill>
-            <a:srgbClr val="272A38"/>
-          </a:solidFill>
-          <a:ln w="12700">
-            <a:solidFill>
-              <a:srgbClr val="272A38"/>
-            </a:solidFill>
-            <a:prstDash val="solid"/>
-          </a:ln>
-        </p:spPr>
-        <p:txBody>
-          <a:bodyPr/>
-          <a:lstStyle/>
-          <a:p>
-            <a:endParaRPr lang="ro-RO"/>
-          </a:p>
-        </p:txBody>
-      </p:sp>
-      <p:sp>
-        <p:nvSpPr>
-          <p:cNvPr id="20" name="Text 18"/>
-          <p:cNvSpPr/>
-          <p:nvPr/>
-        </p:nvSpPr>
-        <p:spPr>
-          <a:xfrm>
-            <a:off x="9144000" y="4892040"/>
-            <a:ext cx="2240280" cy="502920"/>
-          </a:xfrm>
-          <a:prstGeom prst="rect">
-            <a:avLst/>
-          </a:prstGeom>
-          <a:noFill/>
-          <a:ln/>
-        </p:spPr>
-        <p:txBody>
-          <a:bodyPr wrap="square" lIns="0" tIns="0" rIns="0" bIns="0" rtlCol="0" anchor="ctr"/>
-          <a:lstStyle/>
-          <a:p>
-            <a:pPr marL="0" indent="0">
-              <a:buNone/>
-            </a:pPr>
-            <a:r>
-              <a:rPr lang="en-US" sz="1300" b="1" dirty="0">
-                <a:solidFill>
-                  <a:srgbClr val="9B7EF7"/>
-                </a:solidFill>
-                <a:latin typeface="Palatino Linotype" pitchFamily="34" charset="0"/>
-                <a:ea typeface="Palatino Linotype" pitchFamily="34" charset="-122"/>
-                <a:cs typeface="Palatino Linotype" pitchFamily="34" charset="-120"/>
-              </a:rPr>
-              <a:t>Regresie la medie</a:t>
-            </a:r>
-            <a:endParaRPr lang="en-US" sz="1300" dirty="0"/>
-          </a:p>
-        </p:txBody>
-      </p:sp>
-      <p:sp>
-        <p:nvSpPr>
-          <p:cNvPr id="21" name="Text 19"/>
-          <p:cNvSpPr/>
-          <p:nvPr/>
-        </p:nvSpPr>
-        <p:spPr>
-          <a:xfrm>
-            <a:off x="9144000" y="5376672"/>
-            <a:ext cx="2240280" cy="274320"/>
-          </a:xfrm>
-          <a:prstGeom prst="rect">
-            <a:avLst/>
-          </a:prstGeom>
-          <a:noFill/>
-          <a:ln/>
-        </p:spPr>
-        <p:txBody>
-          <a:bodyPr wrap="square" lIns="0" tIns="0" rIns="0" bIns="0" rtlCol="0" anchor="ctr"/>
-          <a:lstStyle/>
-          <a:p>
-            <a:pPr marL="0" indent="0">
-              <a:buNone/>
-            </a:pPr>
-            <a:r>
-              <a:rPr lang="en-US" sz="1000" i="1" dirty="0">
-                <a:solidFill>
-                  <a:srgbClr val="959BB0"/>
-                </a:solidFill>
-                <a:latin typeface="Palatino Linotype" pitchFamily="34" charset="0"/>
-                <a:ea typeface="Palatino Linotype" pitchFamily="34" charset="-122"/>
-                <a:cs typeface="Palatino Linotype" pitchFamily="34" charset="-120"/>
-              </a:rPr>
-              <a:t>statistică</a:t>
             </a:r>
             <a:endParaRPr lang="en-US" sz="1000" dirty="0"/>
           </a:p>
@@ -6667,7 +6559,7 @@
                 <a:ea typeface="Palatino Linotype" pitchFamily="34" charset="-122"/>
                 <a:cs typeface="Palatino Linotype" pitchFamily="34" charset="-120"/>
               </a:rPr>
-              <a:t>Surse: Snow 1855, pp. 51–52 (citat integral). Whitehead, în Cholera Inquiry Committee 1855, p. 162: „the drinkers of the pump water were not so numerous when so many who habitually used it were already dead” — „plausible suggestions”, pe care nu le consideră concludente. McLeod KS. Soc Sci Med. 2000;50(7–8):923–935.</a:t>
+              <a:t>Surse: Snow 1855, pp. 51–52 (citat integral). Whitehead, în Cholera Inquiry Committee 1855, p. 162: „the drinkers of the pump water were not so numerous when so many who habitually used it were already dead” — „plausible suggestions”, pe care nu le consideră concludente.</a:t>
             </a:r>
             <a:endParaRPr lang="en-US" sz="900" dirty="0"/>
           </a:p>
@@ -18503,7 +18395,7 @@
                 <a:ea typeface="Palatino Linotype" pitchFamily="34" charset="-122"/>
                 <a:cs typeface="Palatino Linotype" pitchFamily="34" charset="-120"/>
               </a:rPr>
-              <a:t>Cel puțin două au alt răspuns decât cel pe care îl veți da acum. La una, răspunsul depinde de lista pe care o citiți — o discutăm după pauză.</a:t>
+              <a:t>La una, răspunsul depinde de lista pe care o citiți.</a:t>
             </a:r>
             <a:endParaRPr lang="en-US" sz="1250" dirty="0"/>
           </a:p>
@@ -18976,7 +18868,7 @@
                 <a:ea typeface="Palatino Linotype" pitchFamily="34" charset="-122"/>
                 <a:cs typeface="Palatino Linotype" pitchFamily="34" charset="-120"/>
               </a:rPr>
-              <a:t>Snow a murit în 1858, la 45 de ani. Lucrarea lui nu fusese acceptată.</a:t>
+              <a:t>Snow a murit în 1858, la 45 de ani. Acceptarea largă a lucrării lui a cerut o schimbare majoră a gândirii despre cauzele bolilor.</a:t>
             </a:r>
             <a:endParaRPr lang="en-US" sz="2200" dirty="0"/>
           </a:p>
@@ -19574,7 +19466,7 @@
                 <a:ea typeface="Palatino Linotype" pitchFamily="34" charset="-122"/>
                 <a:cs typeface="Palatino Linotype" pitchFamily="34" charset="-120"/>
               </a:rPr>
-              <a:t>Pacini a DESCRIS vibrionul în 1854; numele Vibrio cholerae Pacini 1854 a fost conservat oficial abia în 1965. Koch l-a identificat din nou în 1883 și l-a izolat în cultură pură; biografia Nobel: în Egipt a descoperit vibrionul și a adus culturi pure în Germania; a studiat holera și în India.</a:t>
+              <a:t>Pacini a DESCRIS vibrionul în 1854; numele Vibrio cholerae Pacini 1854 a fost conservat oficial abia în 1965. Koch a găsit vibrionul în Egipt, în 1883, și a adus culturi pure în Germania; a studiat holera și în India (biografia Nobel).</a:t>
             </a:r>
             <a:endParaRPr lang="en-US" sz="1150" dirty="0"/>
           </a:p>
@@ -19652,7 +19544,7 @@
                 <a:ea typeface="Palatino Linotype" pitchFamily="34" charset="-122"/>
                 <a:cs typeface="Palatino Linotype" pitchFamily="34" charset="-120"/>
               </a:rPr>
-              <a:t>Surse: General Board of Health 1855, p. 48, 52 (verdictul) și 241 (Hassall). Snow 1855, p. 52: „a great number of very minute oval animalcules”, considerate „of no importance”. Lippi D, Gotuzzo E. Clin Microbiol Infect. 2014;20(3):191–195. Opinia 31 (1965). NobelPrize.org, biografia lui Koch.</a:t>
+              <a:t>Surse: General Board of Health 1855, p. 48, 52 (verdictul) și 241 (Hassall). Snow 1855, p. 52: „a great number of very minute oval animalcules”, considerate „of no importance”. LPSN (DSMZ), Vibrio cholerae: Opinia judiciară 31 (1965). NobelPrize.org, biografia lui Koch.</a:t>
             </a:r>
             <a:endParaRPr lang="en-US" sz="900" dirty="0"/>
           </a:p>
@@ -20308,7 +20200,7 @@
                 <a:ea typeface="Palatino Linotype" pitchFamily="34" charset="-122"/>
                 <a:cs typeface="Palatino Linotype" pitchFamily="34" charset="-120"/>
               </a:rPr>
-              <a:t>Snow avea dreptate în 1854. Avea dovezi în 1855. A murit în 1858, înainte ca lucrarea lui să fie acceptată. Nu a fost suficient.</a:t>
+              <a:t>Snow avea dreptate în 1854. Avea dovezi în 1855. A murit în 1858; acceptarea largă a lucrării a cerut o schimbare majoră a gândirii despre cauzele bolilor. Nu a fost suficient.</a:t>
             </a:r>
             <a:endParaRPr lang="en-US" sz="1900" dirty="0"/>
           </a:p>
@@ -22801,7 +22693,7 @@
                 <a:ea typeface="Palatino Linotype" pitchFamily="34" charset="-122"/>
                 <a:cs typeface="Palatino Linotype" pitchFamily="34" charset="-120"/>
               </a:rPr>
-              <a:t>Nivel de evidență</a:t>
+              <a:t>Folosirea în note</a:t>
             </a:r>
             <a:endParaRPr lang="en-US" sz="1200" dirty="0"/>
           </a:p>
@@ -22840,7 +22732,7 @@
                 <a:ea typeface="Palatino Linotype" pitchFamily="34" charset="-122"/>
                 <a:cs typeface="Palatino Linotype" pitchFamily="34" charset="-120"/>
               </a:rPr>
-              <a:t>VII pe scara Melnyk &amp; Fineout-Overholt — cel mai de jos</a:t>
+              <a:t>nu declară ediție, an sau recenzie; notele nu îl folosesc ca sursă pentru definiții</a:t>
             </a:r>
             <a:endParaRPr lang="en-US" sz="1150" dirty="0"/>
           </a:p>
@@ -26244,7 +26136,7 @@
                 <a:ea typeface="Palatino Linotype" pitchFamily="34" charset="-122"/>
                 <a:cs typeface="Palatino Linotype" pitchFamily="34" charset="-120"/>
               </a:rPr>
-              <a:t>ulterior</a:t>
+              <a:t>2019</a:t>
             </a:r>
             <a:endParaRPr lang="en-US" sz="1200" dirty="0"/>
           </a:p>
@@ -26322,7 +26214,7 @@
                 <a:ea typeface="Palatino Linotype" pitchFamily="34" charset="-122"/>
                 <a:cs typeface="Palatino Linotype" pitchFamily="34" charset="-120"/>
               </a:rPr>
-              <a:t>—</a:t>
+              <a:t>10</a:t>
             </a:r>
             <a:endParaRPr lang="en-US" sz="1150" dirty="0"/>
           </a:p>
@@ -26395,7 +26287,7 @@
                 <a:ea typeface="Palatino Linotype" pitchFamily="34" charset="-122"/>
                 <a:cs typeface="Palatino Linotype" pitchFamily="34" charset="-120"/>
               </a:rPr>
-              <a:t>Documentul-sursă avertizează el însuși: „The lists of steps for outbreak investigations must not be taken to literally.” Numărul diferă între liste; la evaluare se folosește lista de zece etape de pe diapozitivul anterior. Contează ordinea: dacă formulați ipoteza înaintea definiției de caz, veți găsi exact cazurile care v-o confirmă.</a:t>
+              <a:t>Documentul-sursă avertizează el însuși: „The lists of steps for outbreak investigations must not be taken to literally.” Numărul diferă între liste și nu se cere la evaluare. Contează ordinea logică: dacă formulați ipoteza înaintea definiției de caz, veți găsi exact cazurile care v-o confirmă.</a:t>
             </a:r>
             <a:endParaRPr lang="en-US" sz="1250" dirty="0"/>
           </a:p>
@@ -26448,7 +26340,7 @@
 </p:sld>
 </file>
 
-<file path=ppt/slides/slide43.xml><?xml version="1.0" encoding="utf-8"?>
+<file path=ppt/slides/slide41.xml><?xml version="1.0" encoding="utf-8"?>
 <p:sld xmlns:a="http://schemas.openxmlformats.org/drawingml/2006/main" xmlns:r="http://schemas.openxmlformats.org/officeDocument/2006/relationships" xmlns:p="http://schemas.openxmlformats.org/presentationml/2006/main">
   <p:cSld name="Slide 43">
     <p:bg>
@@ -27360,7 +27252,7 @@
 </p:sld>
 </file>
 
-<file path=ppt/slides/slide44.xml><?xml version="1.0" encoding="utf-8"?>
+<file path=ppt/slides/slide42.xml><?xml version="1.0" encoding="utf-8"?>
 <p:sld xmlns:a="http://schemas.openxmlformats.org/drawingml/2006/main" xmlns:r="http://schemas.openxmlformats.org/officeDocument/2006/relationships" xmlns:p="http://schemas.openxmlformats.org/presentationml/2006/main">
   <p:cSld name="Slide 44">
     <p:bg>
@@ -27418,7 +27310,7 @@
                 <a:ea typeface="Palatino Linotype" pitchFamily="34" charset="-122"/>
                 <a:cs typeface="Palatino Linotype" pitchFamily="34" charset="-120"/>
               </a:rPr>
-              <a:t>JACK-IN-THE-BOX · DOZA INFECTANTĂ</a:t>
+              <a:t>JACK IN THE BOX · DOZA INFECTANTĂ</a:t>
             </a:r>
             <a:endParaRPr lang="en-US" sz="1150" dirty="0"/>
           </a:p>
@@ -27871,7 +27763,7 @@
                 <a:ea typeface="Palatino Linotype" pitchFamily="34" charset="-122"/>
                 <a:cs typeface="Palatino Linotype" pitchFamily="34" charset="-120"/>
               </a:rPr>
-              <a:t>Reflexul învățat prost spune: primul e „semnificativ statistic”, al doilea nu. Uitați-vă la LĂȚIMI: amândouă sunt imprecise. Iar studiile nu sunt comparabile: în California, martori din comunitate; în Nevada, însoțitori de masă. Este capcana 7, în formă modernă.</a:t>
+              <a:t>Reflexul învățat greșit spune: primul e „semnificativ statistic”, al doilea nu. Uitați-vă la LĂȚIMI: amândouă sunt imprecise. Iar studiile nu sunt comparabile: în California, martori din comunitate; în Nevada, însoțitori de masă. Este capcana 7, în formă modernă.</a:t>
             </a:r>
             <a:endParaRPr lang="en-US" sz="1300" dirty="0"/>
           </a:p>
@@ -27983,7 +27875,7 @@
                 <a:ea typeface="Palatino Linotype" pitchFamily="34" charset="-122"/>
                 <a:cs typeface="Palatino Linotype" pitchFamily="34" charset="-120"/>
               </a:rPr>
-              <a:t>Surse: CDC. MMWR. 1993;42(14):259–261 (rapoartele cotelor) · Tuttle J et al. Epidemiol Infect. 1999;122(2):185–192. DOI: 10.1017/s0950268898001976 · Bell BP et al. JAMA. 1994;272(17):1349–1353.</a:t>
+              <a:t>Surse: CDC. MMWR. 1993;42(14):259–261 (rapoartele cotelor) · Tuttle J et al. Epidemiol Infect. 1999;122(2):185–192. DOI: 10.1017/s0950268898001976</a:t>
             </a:r>
             <a:endParaRPr lang="en-US" sz="900" dirty="0"/>
           </a:p>
@@ -28014,7 +27906,7 @@
 </p:sld>
 </file>
 
-<file path=ppt/slides/slide45.xml><?xml version="1.0" encoding="utf-8"?>
+<file path=ppt/slides/slide43.xml><?xml version="1.0" encoding="utf-8"?>
 <p:sld xmlns:a="http://schemas.openxmlformats.org/drawingml/2006/main" xmlns:r="http://schemas.openxmlformats.org/officeDocument/2006/relationships" xmlns:p="http://schemas.openxmlformats.org/presentationml/2006/main">
   <p:cSld name="Slide 7">
     <p:bg>
@@ -28646,7 +28538,7 @@
 </p:sld>
 </file>
 
-<file path=ppt/slides/slide46.xml><?xml version="1.0" encoding="utf-8"?>
+<file path=ppt/slides/slide44.xml><?xml version="1.0" encoding="utf-8"?>
 <p:sld xmlns:a="http://schemas.openxmlformats.org/drawingml/2006/main" xmlns:r="http://schemas.openxmlformats.org/officeDocument/2006/relationships" xmlns:p="http://schemas.openxmlformats.org/presentationml/2006/main">
   <p:cSld name="Slide 45">
     <p:bg>
@@ -29797,7 +29689,7 @@
 </p:sld>
 </file>
 
-<file path=ppt/slides/slide47.xml><?xml version="1.0" encoding="utf-8"?>
+<file path=ppt/slides/slide45.xml><?xml version="1.0" encoding="utf-8"?>
 <p:sld xmlns:a="http://schemas.openxmlformats.org/drawingml/2006/main" xmlns:r="http://schemas.openxmlformats.org/officeDocument/2006/relationships" xmlns:p="http://schemas.openxmlformats.org/presentationml/2006/main">
   <p:cSld name="Slide 46">
     <p:bg>
@@ -30972,7 +30864,7 @@
 </p:sld>
 </file>
 
-<file path=ppt/slides/slide48.xml><?xml version="1.0" encoding="utf-8"?>
+<file path=ppt/slides/slide46.xml><?xml version="1.0" encoding="utf-8"?>
 <p:sld xmlns:a="http://schemas.openxmlformats.org/drawingml/2006/main" xmlns:r="http://schemas.openxmlformats.org/officeDocument/2006/relationships" xmlns:p="http://schemas.openxmlformats.org/presentationml/2006/main">
   <p:cSld name="Slide 47">
     <p:bg>
@@ -31204,7 +31096,7 @@
                 <a:ea typeface="Palatino Linotype" pitchFamily="34" charset="-122"/>
                 <a:cs typeface="Palatino Linotype" pitchFamily="34" charset="-120"/>
               </a:rPr>
-              <a:t>Ce există: un genom din a doua pandemie, reconstruit din intestinul conservat al unei victime din Philadelphia, 1849 — 203 variații de un nucleotid față de tulpina clasică O395. NCTC 30, izolată în 1916, nu aparține liniilor pandemice.</a:t>
+              <a:t>Ce există: un genom din a doua pandemie, reconstruit din stomacul conservat al unei victime din Philadelphia, 1849 — 203 variații de un nucleotid față de tulpina clasică O395. NCTC 30, izolată în 1916, nu aparține liniilor pandemice.</a:t>
             </a:r>
             <a:endParaRPr lang="en-US" sz="1250" dirty="0"/>
           </a:p>
@@ -31524,7 +31416,7 @@
                 <a:ea typeface="Palatino Linotype" pitchFamily="34" charset="-122"/>
                 <a:cs typeface="Palatino Linotype" pitchFamily="34" charset="-120"/>
               </a:rPr>
-              <a:t>Surse: Devault AM et al. N Engl J Med. 2014;370(4):334–340. DOI: 10.1056/NEJMoa1308663 · Dorman MJ et al. Proc Biol Sci. 2019;286(1900):20182025. DOI: 10.1098/rspb.2018.2025 · Directiva (UE) 2024/3019, art. 17 și 33.</a:t>
+              <a:t>Surse: Malyarchuk AB et al. Biochemistry (Mosc). 2022;87(3):242–258. DOI: 10.1134/S0006297922030051 · Dorman MJ et al. Proc Biol Sci. 2019;286(1900):20182025. DOI: 10.1098/rspb.2018.2025 · Directiva (UE) 2024/3019, art. 17 și 33.</a:t>
             </a:r>
             <a:endParaRPr lang="en-US" sz="900" dirty="0"/>
           </a:p>
@@ -31538,7 +31430,7 @@
 </p:sld>
 </file>
 
-<file path=ppt/slides/slide49.xml><?xml version="1.0" encoding="utf-8"?>
+<file path=ppt/slides/slide47.xml><?xml version="1.0" encoding="utf-8"?>
 <p:sld xmlns:a="http://schemas.openxmlformats.org/drawingml/2006/main" xmlns:r="http://schemas.openxmlformats.org/officeDocument/2006/relationships" xmlns:p="http://schemas.openxmlformats.org/presentationml/2006/main">
   <p:cSld name="Slide 48">
     <p:bg>
@@ -32753,6 +32645,2005 @@
               <a:t>Nu arta de a avea dreptate spectaculos. Arta de a construi GRUPUL DE COMPARAȚIE înainte ca cineva să te creadă — și de a lucra mai departe după ce nu te-a crezut.</a:t>
             </a:r>
             <a:endParaRPr lang="en-US" sz="1350" dirty="0"/>
+          </a:p>
+        </p:txBody>
+      </p:sp>
+    </p:spTree>
+  </p:cSld>
+  <p:clrMapOvr>
+    <a:masterClrMapping/>
+  </p:clrMapOvr>
+</p:sld>
+</file>
+
+<file path=ppt/slides/slide48.xml><?xml version="1.0" encoding="utf-8"?>
+<p:sld xmlns:a="http://schemas.openxmlformats.org/drawingml/2006/main" xmlns:r="http://schemas.openxmlformats.org/officeDocument/2006/relationships" xmlns:p="http://schemas.openxmlformats.org/presentationml/2006/main">
+  <p:cSld name="Slide 49">
+    <p:bg>
+      <p:bgPr>
+        <a:solidFill>
+          <a:srgbClr val="11121A"/>
+        </a:solidFill>
+        <a:effectLst/>
+      </p:bgPr>
+    </p:bg>
+    <p:spTree>
+      <p:nvGrpSpPr>
+        <p:cNvPr id="1" name=""/>
+        <p:cNvGrpSpPr/>
+        <p:nvPr/>
+      </p:nvGrpSpPr>
+      <p:grpSpPr>
+        <a:xfrm>
+          <a:off x="0" y="0"/>
+          <a:ext cx="0" cy="0"/>
+          <a:chOff x="0" y="0"/>
+          <a:chExt cx="0" cy="0"/>
+        </a:xfrm>
+      </p:grpSpPr>
+      <p:sp>
+        <p:nvSpPr>
+          <p:cNvPr id="2" name="Text 0"/>
+          <p:cNvSpPr/>
+          <p:nvPr/>
+        </p:nvSpPr>
+        <p:spPr>
+          <a:xfrm>
+            <a:off x="594360" y="365760"/>
+            <a:ext cx="8229600" cy="310896"/>
+          </a:xfrm>
+          <a:prstGeom prst="rect">
+            <a:avLst/>
+          </a:prstGeom>
+          <a:noFill/>
+          <a:ln/>
+        </p:spPr>
+        <p:txBody>
+          <a:bodyPr wrap="square" lIns="0" tIns="0" rIns="0" bIns="0" rtlCol="0" anchor="ctr"/>
+          <a:lstStyle/>
+          <a:p>
+            <a:pPr marL="0" indent="0">
+              <a:buNone/>
+            </a:pPr>
+            <a:r>
+              <a:rPr lang="en-US" sz="1150" b="1" kern="0" spc="300" dirty="0">
+                <a:solidFill>
+                  <a:srgbClr val="FF4757"/>
+                </a:solidFill>
+                <a:latin typeface="Palatino Linotype" pitchFamily="34" charset="0"/>
+                <a:ea typeface="Palatino Linotype" pitchFamily="34" charset="-122"/>
+                <a:cs typeface="Palatino Linotype" pitchFamily="34" charset="-120"/>
+              </a:rPr>
+              <a:t>CINCI REGULI</a:t>
+            </a:r>
+            <a:endParaRPr lang="en-US" sz="1150" dirty="0"/>
+          </a:p>
+        </p:txBody>
+      </p:sp>
+      <p:sp>
+        <p:nvSpPr>
+          <p:cNvPr id="3" name="Text 1"/>
+          <p:cNvSpPr/>
+          <p:nvPr/>
+        </p:nvSpPr>
+        <p:spPr>
+          <a:xfrm>
+            <a:off x="594360" y="694944"/>
+            <a:ext cx="10972800" cy="960120"/>
+          </a:xfrm>
+          <a:prstGeom prst="rect">
+            <a:avLst/>
+          </a:prstGeom>
+          <a:noFill/>
+          <a:ln/>
+        </p:spPr>
+        <p:txBody>
+          <a:bodyPr wrap="square" lIns="0" tIns="0" rIns="0" bIns="0" rtlCol="0" anchor="t"/>
+          <a:lstStyle/>
+          <a:p>
+            <a:pPr marL="0" indent="0">
+              <a:buNone/>
+            </a:pPr>
+            <a:r>
+              <a:rPr lang="en-US" sz="3100" b="1" dirty="0">
+                <a:solidFill>
+                  <a:srgbClr val="FFFFFF"/>
+                </a:solidFill>
+                <a:latin typeface="Palatino Linotype" pitchFamily="34" charset="0"/>
+                <a:ea typeface="Palatino Linotype" pitchFamily="34" charset="-122"/>
+                <a:cs typeface="Palatino Linotype" pitchFamily="34" charset="-120"/>
+              </a:rPr>
+              <a:t>Ce luați cu voi</a:t>
+            </a:r>
+            <a:endParaRPr lang="en-US" sz="3100" dirty="0"/>
+          </a:p>
+        </p:txBody>
+      </p:sp>
+      <p:sp>
+        <p:nvSpPr>
+          <p:cNvPr id="4" name="Shape 2"/>
+          <p:cNvSpPr/>
+          <p:nvPr/>
+        </p:nvSpPr>
+        <p:spPr>
+          <a:xfrm>
+            <a:off x="594360" y="1691640"/>
+            <a:ext cx="10972800" cy="786384"/>
+          </a:xfrm>
+          <a:prstGeom prst="roundRect">
+            <a:avLst>
+              <a:gd name="adj" fmla="val 10465"/>
+            </a:avLst>
+          </a:prstGeom>
+          <a:solidFill>
+            <a:srgbClr val="1D1F2B"/>
+          </a:solidFill>
+          <a:ln w="12700">
+            <a:solidFill>
+              <a:srgbClr val="1D1F2B"/>
+            </a:solidFill>
+            <a:prstDash val="solid"/>
+          </a:ln>
+        </p:spPr>
+        <p:txBody>
+          <a:bodyPr/>
+          <a:lstStyle/>
+          <a:p>
+            <a:endParaRPr lang="ro-RO"/>
+          </a:p>
+        </p:txBody>
+      </p:sp>
+      <p:sp>
+        <p:nvSpPr>
+          <p:cNvPr id="5" name="Shape 3"/>
+          <p:cNvSpPr/>
+          <p:nvPr/>
+        </p:nvSpPr>
+        <p:spPr>
+          <a:xfrm>
+            <a:off x="914400" y="1874520"/>
+            <a:ext cx="438912" cy="438912"/>
+          </a:xfrm>
+          <a:prstGeom prst="ellipse">
+            <a:avLst/>
+          </a:prstGeom>
+          <a:solidFill>
+            <a:srgbClr val="FF4757"/>
+          </a:solidFill>
+          <a:ln/>
+        </p:spPr>
+        <p:txBody>
+          <a:bodyPr/>
+          <a:lstStyle/>
+          <a:p>
+            <a:endParaRPr lang="ro-RO"/>
+          </a:p>
+        </p:txBody>
+      </p:sp>
+      <p:sp>
+        <p:nvSpPr>
+          <p:cNvPr id="6" name="Text 4"/>
+          <p:cNvSpPr/>
+          <p:nvPr/>
+        </p:nvSpPr>
+        <p:spPr>
+          <a:xfrm>
+            <a:off x="914400" y="1874520"/>
+            <a:ext cx="438912" cy="438912"/>
+          </a:xfrm>
+          <a:prstGeom prst="rect">
+            <a:avLst/>
+          </a:prstGeom>
+          <a:noFill/>
+          <a:ln/>
+        </p:spPr>
+        <p:txBody>
+          <a:bodyPr wrap="square" lIns="0" tIns="0" rIns="0" bIns="0" rtlCol="0" anchor="ctr"/>
+          <a:lstStyle/>
+          <a:p>
+            <a:pPr marL="0" indent="0" algn="ctr">
+              <a:buNone/>
+            </a:pPr>
+            <a:r>
+              <a:rPr lang="en-US" sz="1400" b="1" dirty="0">
+                <a:solidFill>
+                  <a:srgbClr val="11121A"/>
+                </a:solidFill>
+                <a:latin typeface="Palatino Linotype" pitchFamily="34" charset="0"/>
+                <a:ea typeface="Palatino Linotype" pitchFamily="34" charset="-122"/>
+                <a:cs typeface="Palatino Linotype" pitchFamily="34" charset="-120"/>
+              </a:rPr>
+              <a:t>1</a:t>
+            </a:r>
+            <a:endParaRPr lang="en-US" sz="1400" dirty="0"/>
+          </a:p>
+        </p:txBody>
+      </p:sp>
+      <p:sp>
+        <p:nvSpPr>
+          <p:cNvPr id="7" name="Text 5"/>
+          <p:cNvSpPr/>
+          <p:nvPr/>
+        </p:nvSpPr>
+        <p:spPr>
+          <a:xfrm>
+            <a:off x="1600200" y="1746504"/>
+            <a:ext cx="9692640" cy="347472"/>
+          </a:xfrm>
+          <a:prstGeom prst="rect">
+            <a:avLst/>
+          </a:prstGeom>
+          <a:noFill/>
+          <a:ln/>
+        </p:spPr>
+        <p:txBody>
+          <a:bodyPr wrap="square" lIns="0" tIns="0" rIns="0" bIns="0" rtlCol="0" anchor="ctr"/>
+          <a:lstStyle/>
+          <a:p>
+            <a:pPr marL="0" indent="0">
+              <a:buNone/>
+            </a:pPr>
+            <a:r>
+              <a:rPr lang="en-US" sz="1450" b="1" dirty="0">
+                <a:solidFill>
+                  <a:srgbClr val="FF4757"/>
+                </a:solidFill>
+                <a:latin typeface="Palatino Linotype" pitchFamily="34" charset="0"/>
+                <a:ea typeface="Palatino Linotype" pitchFamily="34" charset="-122"/>
+                <a:cs typeface="Palatino Linotype" pitchFamily="34" charset="-120"/>
+              </a:rPr>
+              <a:t>Cereți numitorul — și apoi grupul de comparație.</a:t>
+            </a:r>
+            <a:endParaRPr lang="en-US" sz="1450" dirty="0"/>
+          </a:p>
+        </p:txBody>
+      </p:sp>
+      <p:sp>
+        <p:nvSpPr>
+          <p:cNvPr id="8" name="Text 6"/>
+          <p:cNvSpPr/>
+          <p:nvPr/>
+        </p:nvSpPr>
+        <p:spPr>
+          <a:xfrm>
+            <a:off x="1600200" y="2093976"/>
+            <a:ext cx="9692640" cy="365760"/>
+          </a:xfrm>
+          <a:prstGeom prst="rect">
+            <a:avLst/>
+          </a:prstGeom>
+          <a:noFill/>
+          <a:ln/>
+        </p:spPr>
+        <p:txBody>
+          <a:bodyPr wrap="square" lIns="0" tIns="0" rIns="0" bIns="0" rtlCol="0" anchor="ctr"/>
+          <a:lstStyle/>
+          <a:p>
+            <a:pPr marL="0" indent="0">
+              <a:buNone/>
+            </a:pPr>
+            <a:r>
+              <a:rPr lang="en-US" sz="1150" dirty="0">
+                <a:solidFill>
+                  <a:srgbClr val="FFFFFF"/>
+                </a:solidFill>
+                <a:latin typeface="Palatino Linotype" pitchFamily="34" charset="0"/>
+                <a:ea typeface="Palatino Linotype" pitchFamily="34" charset="-122"/>
+                <a:cs typeface="Palatino Linotype" pitchFamily="34" charset="-120"/>
+              </a:rPr>
+              <a:t>Numitorul e necesar și nu e suficient: Farr avea numitor și greșea. Ce decide este alocarea neconfundată.</a:t>
+            </a:r>
+            <a:endParaRPr lang="en-US" sz="1150" dirty="0"/>
+          </a:p>
+        </p:txBody>
+      </p:sp>
+      <p:sp>
+        <p:nvSpPr>
+          <p:cNvPr id="9" name="Shape 7"/>
+          <p:cNvSpPr/>
+          <p:nvPr/>
+        </p:nvSpPr>
+        <p:spPr>
+          <a:xfrm>
+            <a:off x="594360" y="2587752"/>
+            <a:ext cx="10972800" cy="786384"/>
+          </a:xfrm>
+          <a:prstGeom prst="roundRect">
+            <a:avLst>
+              <a:gd name="adj" fmla="val 10465"/>
+            </a:avLst>
+          </a:prstGeom>
+          <a:solidFill>
+            <a:srgbClr val="272A38"/>
+          </a:solidFill>
+          <a:ln w="12700">
+            <a:solidFill>
+              <a:srgbClr val="272A38"/>
+            </a:solidFill>
+            <a:prstDash val="solid"/>
+          </a:ln>
+        </p:spPr>
+        <p:txBody>
+          <a:bodyPr/>
+          <a:lstStyle/>
+          <a:p>
+            <a:endParaRPr lang="ro-RO"/>
+          </a:p>
+        </p:txBody>
+      </p:sp>
+      <p:sp>
+        <p:nvSpPr>
+          <p:cNvPr id="10" name="Shape 8"/>
+          <p:cNvSpPr/>
+          <p:nvPr/>
+        </p:nvSpPr>
+        <p:spPr>
+          <a:xfrm>
+            <a:off x="914400" y="2770632"/>
+            <a:ext cx="438912" cy="438912"/>
+          </a:xfrm>
+          <a:prstGeom prst="ellipse">
+            <a:avLst/>
+          </a:prstGeom>
+          <a:solidFill>
+            <a:srgbClr val="FFC24B"/>
+          </a:solidFill>
+          <a:ln/>
+        </p:spPr>
+        <p:txBody>
+          <a:bodyPr/>
+          <a:lstStyle/>
+          <a:p>
+            <a:endParaRPr lang="ro-RO"/>
+          </a:p>
+        </p:txBody>
+      </p:sp>
+      <p:sp>
+        <p:nvSpPr>
+          <p:cNvPr id="11" name="Text 9"/>
+          <p:cNvSpPr/>
+          <p:nvPr/>
+        </p:nvSpPr>
+        <p:spPr>
+          <a:xfrm>
+            <a:off x="914400" y="2770632"/>
+            <a:ext cx="438912" cy="438912"/>
+          </a:xfrm>
+          <a:prstGeom prst="rect">
+            <a:avLst/>
+          </a:prstGeom>
+          <a:noFill/>
+          <a:ln/>
+        </p:spPr>
+        <p:txBody>
+          <a:bodyPr wrap="square" lIns="0" tIns="0" rIns="0" bIns="0" rtlCol="0" anchor="ctr"/>
+          <a:lstStyle/>
+          <a:p>
+            <a:pPr marL="0" indent="0" algn="ctr">
+              <a:buNone/>
+            </a:pPr>
+            <a:r>
+              <a:rPr lang="en-US" sz="1400" b="1" dirty="0">
+                <a:solidFill>
+                  <a:srgbClr val="11121A"/>
+                </a:solidFill>
+                <a:latin typeface="Palatino Linotype" pitchFamily="34" charset="0"/>
+                <a:ea typeface="Palatino Linotype" pitchFamily="34" charset="-122"/>
+                <a:cs typeface="Palatino Linotype" pitchFamily="34" charset="-120"/>
+              </a:rPr>
+              <a:t>2</a:t>
+            </a:r>
+            <a:endParaRPr lang="en-US" sz="1400" dirty="0"/>
+          </a:p>
+        </p:txBody>
+      </p:sp>
+      <p:sp>
+        <p:nvSpPr>
+          <p:cNvPr id="12" name="Text 10"/>
+          <p:cNvSpPr/>
+          <p:nvPr/>
+        </p:nvSpPr>
+        <p:spPr>
+          <a:xfrm>
+            <a:off x="1600200" y="2642616"/>
+            <a:ext cx="9692640" cy="347472"/>
+          </a:xfrm>
+          <a:prstGeom prst="rect">
+            <a:avLst/>
+          </a:prstGeom>
+          <a:noFill/>
+          <a:ln/>
+        </p:spPr>
+        <p:txBody>
+          <a:bodyPr wrap="square" lIns="0" tIns="0" rIns="0" bIns="0" rtlCol="0" anchor="ctr"/>
+          <a:lstStyle/>
+          <a:p>
+            <a:pPr marL="0" indent="0">
+              <a:buNone/>
+            </a:pPr>
+            <a:r>
+              <a:rPr lang="en-US" sz="1450" b="1" dirty="0">
+                <a:solidFill>
+                  <a:srgbClr val="FFC24B"/>
+                </a:solidFill>
+                <a:latin typeface="Palatino Linotype" pitchFamily="34" charset="0"/>
+                <a:ea typeface="Palatino Linotype" pitchFamily="34" charset="-122"/>
+                <a:cs typeface="Palatino Linotype" pitchFamily="34" charset="-120"/>
+              </a:rPr>
+              <a:t>Căutați excepția aparentă.</a:t>
+            </a:r>
+            <a:endParaRPr lang="en-US" sz="1450" dirty="0"/>
+          </a:p>
+        </p:txBody>
+      </p:sp>
+      <p:sp>
+        <p:nvSpPr>
+          <p:cNvPr id="13" name="Text 11"/>
+          <p:cNvSpPr/>
+          <p:nvPr/>
+        </p:nvSpPr>
+        <p:spPr>
+          <a:xfrm>
+            <a:off x="1600200" y="2990088"/>
+            <a:ext cx="9692640" cy="365760"/>
+          </a:xfrm>
+          <a:prstGeom prst="rect">
+            <a:avLst/>
+          </a:prstGeom>
+          <a:noFill/>
+          <a:ln/>
+        </p:spPr>
+        <p:txBody>
+          <a:bodyPr wrap="square" lIns="0" tIns="0" rIns="0" bIns="0" rtlCol="0" anchor="ctr"/>
+          <a:lstStyle/>
+          <a:p>
+            <a:pPr marL="0" indent="0">
+              <a:buNone/>
+            </a:pPr>
+            <a:r>
+              <a:rPr lang="en-US" sz="1150" dirty="0">
+                <a:solidFill>
+                  <a:srgbClr val="FFFFFF"/>
+                </a:solidFill>
+                <a:latin typeface="Palatino Linotype" pitchFamily="34" charset="0"/>
+                <a:ea typeface="Palatino Linotype" pitchFamily="34" charset="-122"/>
+                <a:cs typeface="Palatino Linotype" pitchFamily="34" charset="-120"/>
+              </a:rPr>
+              <a:t>Nu „cine s-a îmbolnăvit?”, ci „cine părea expus și NU s-a îmbolnăvit?” — cu condiția să declarați ce anume mai diferea între grupuri.</a:t>
+            </a:r>
+            <a:endParaRPr lang="en-US" sz="1150" dirty="0"/>
+          </a:p>
+        </p:txBody>
+      </p:sp>
+      <p:sp>
+        <p:nvSpPr>
+          <p:cNvPr id="14" name="Shape 12"/>
+          <p:cNvSpPr/>
+          <p:nvPr/>
+        </p:nvSpPr>
+        <p:spPr>
+          <a:xfrm>
+            <a:off x="594360" y="3483864"/>
+            <a:ext cx="10972800" cy="786384"/>
+          </a:xfrm>
+          <a:prstGeom prst="roundRect">
+            <a:avLst>
+              <a:gd name="adj" fmla="val 10465"/>
+            </a:avLst>
+          </a:prstGeom>
+          <a:solidFill>
+            <a:srgbClr val="1D1F2B"/>
+          </a:solidFill>
+          <a:ln w="12700">
+            <a:solidFill>
+              <a:srgbClr val="1D1F2B"/>
+            </a:solidFill>
+            <a:prstDash val="solid"/>
+          </a:ln>
+        </p:spPr>
+        <p:txBody>
+          <a:bodyPr/>
+          <a:lstStyle/>
+          <a:p>
+            <a:endParaRPr lang="ro-RO"/>
+          </a:p>
+        </p:txBody>
+      </p:sp>
+      <p:sp>
+        <p:nvSpPr>
+          <p:cNvPr id="15" name="Shape 13"/>
+          <p:cNvSpPr/>
+          <p:nvPr/>
+        </p:nvSpPr>
+        <p:spPr>
+          <a:xfrm>
+            <a:off x="914400" y="3666744"/>
+            <a:ext cx="438912" cy="438912"/>
+          </a:xfrm>
+          <a:prstGeom prst="ellipse">
+            <a:avLst/>
+          </a:prstGeom>
+          <a:solidFill>
+            <a:srgbClr val="27D3BE"/>
+          </a:solidFill>
+          <a:ln/>
+        </p:spPr>
+        <p:txBody>
+          <a:bodyPr/>
+          <a:lstStyle/>
+          <a:p>
+            <a:endParaRPr lang="ro-RO"/>
+          </a:p>
+        </p:txBody>
+      </p:sp>
+      <p:sp>
+        <p:nvSpPr>
+          <p:cNvPr id="16" name="Text 14"/>
+          <p:cNvSpPr/>
+          <p:nvPr/>
+        </p:nvSpPr>
+        <p:spPr>
+          <a:xfrm>
+            <a:off x="914400" y="3666744"/>
+            <a:ext cx="438912" cy="438912"/>
+          </a:xfrm>
+          <a:prstGeom prst="rect">
+            <a:avLst/>
+          </a:prstGeom>
+          <a:noFill/>
+          <a:ln/>
+        </p:spPr>
+        <p:txBody>
+          <a:bodyPr wrap="square" lIns="0" tIns="0" rIns="0" bIns="0" rtlCol="0" anchor="ctr"/>
+          <a:lstStyle/>
+          <a:p>
+            <a:pPr marL="0" indent="0" algn="ctr">
+              <a:buNone/>
+            </a:pPr>
+            <a:r>
+              <a:rPr lang="en-US" sz="1400" b="1" dirty="0">
+                <a:solidFill>
+                  <a:srgbClr val="11121A"/>
+                </a:solidFill>
+                <a:latin typeface="Palatino Linotype" pitchFamily="34" charset="0"/>
+                <a:ea typeface="Palatino Linotype" pitchFamily="34" charset="-122"/>
+                <a:cs typeface="Palatino Linotype" pitchFamily="34" charset="-120"/>
+              </a:rPr>
+              <a:t>3</a:t>
+            </a:r>
+            <a:endParaRPr lang="en-US" sz="1400" dirty="0"/>
+          </a:p>
+        </p:txBody>
+      </p:sp>
+      <p:sp>
+        <p:nvSpPr>
+          <p:cNvPr id="17" name="Text 15"/>
+          <p:cNvSpPr/>
+          <p:nvPr/>
+        </p:nvSpPr>
+        <p:spPr>
+          <a:xfrm>
+            <a:off x="1600200" y="3538728"/>
+            <a:ext cx="9692640" cy="347472"/>
+          </a:xfrm>
+          <a:prstGeom prst="rect">
+            <a:avLst/>
+          </a:prstGeom>
+          <a:noFill/>
+          <a:ln/>
+        </p:spPr>
+        <p:txBody>
+          <a:bodyPr wrap="square" lIns="0" tIns="0" rIns="0" bIns="0" rtlCol="0" anchor="ctr"/>
+          <a:lstStyle/>
+          <a:p>
+            <a:pPr marL="0" indent="0">
+              <a:buNone/>
+            </a:pPr>
+            <a:r>
+              <a:rPr lang="en-US" sz="1450" b="1" dirty="0">
+                <a:solidFill>
+                  <a:srgbClr val="27D3BE"/>
+                </a:solidFill>
+                <a:latin typeface="Palatino Linotype" pitchFamily="34" charset="0"/>
+                <a:ea typeface="Palatino Linotype" pitchFamily="34" charset="-122"/>
+                <a:cs typeface="Palatino Linotype" pitchFamily="34" charset="-120"/>
+              </a:rPr>
+              <a:t>Acționați sub incertitudine, fără să confundați acțiunea cu dovada.</a:t>
+            </a:r>
+            <a:endParaRPr lang="en-US" sz="1450" dirty="0"/>
+          </a:p>
+        </p:txBody>
+      </p:sp>
+      <p:sp>
+        <p:nvSpPr>
+          <p:cNvPr id="18" name="Text 16"/>
+          <p:cNvSpPr/>
+          <p:nvPr/>
+        </p:nvSpPr>
+        <p:spPr>
+          <a:xfrm>
+            <a:off x="1600200" y="3886200"/>
+            <a:ext cx="9692640" cy="365760"/>
+          </a:xfrm>
+          <a:prstGeom prst="rect">
+            <a:avLst/>
+          </a:prstGeom>
+          <a:noFill/>
+          <a:ln/>
+        </p:spPr>
+        <p:txBody>
+          <a:bodyPr wrap="square" lIns="0" tIns="0" rIns="0" bIns="0" rtlCol="0" anchor="ctr"/>
+          <a:lstStyle/>
+          <a:p>
+            <a:pPr marL="0" indent="0">
+              <a:buNone/>
+            </a:pPr>
+            <a:r>
+              <a:rPr lang="en-US" sz="1150" dirty="0">
+                <a:solidFill>
+                  <a:srgbClr val="FFFFFF"/>
+                </a:solidFill>
+                <a:latin typeface="Palatino Linotype" pitchFamily="34" charset="0"/>
+                <a:ea typeface="Palatino Linotype" pitchFamily="34" charset="-122"/>
+                <a:cs typeface="Palatino Linotype" pitchFamily="34" charset="-120"/>
+              </a:rPr>
+              <a:t>Mânerul a fost probabil scos corect, deși atacurile scădeau deja. În Guineea au trecut aproape trei luni între debutul primului caz și alertarea OMS.</a:t>
+            </a:r>
+            <a:endParaRPr lang="en-US" sz="1150" dirty="0"/>
+          </a:p>
+        </p:txBody>
+      </p:sp>
+      <p:sp>
+        <p:nvSpPr>
+          <p:cNvPr id="19" name="Shape 17"/>
+          <p:cNvSpPr/>
+          <p:nvPr/>
+        </p:nvSpPr>
+        <p:spPr>
+          <a:xfrm>
+            <a:off x="594360" y="4379976"/>
+            <a:ext cx="10972800" cy="786384"/>
+          </a:xfrm>
+          <a:prstGeom prst="roundRect">
+            <a:avLst>
+              <a:gd name="adj" fmla="val 10465"/>
+            </a:avLst>
+          </a:prstGeom>
+          <a:solidFill>
+            <a:srgbClr val="2A2438"/>
+          </a:solidFill>
+          <a:ln w="12700">
+            <a:solidFill>
+              <a:srgbClr val="2A2438"/>
+            </a:solidFill>
+            <a:prstDash val="solid"/>
+          </a:ln>
+        </p:spPr>
+        <p:txBody>
+          <a:bodyPr/>
+          <a:lstStyle/>
+          <a:p>
+            <a:endParaRPr lang="ro-RO"/>
+          </a:p>
+        </p:txBody>
+      </p:sp>
+      <p:sp>
+        <p:nvSpPr>
+          <p:cNvPr id="20" name="Shape 18"/>
+          <p:cNvSpPr/>
+          <p:nvPr/>
+        </p:nvSpPr>
+        <p:spPr>
+          <a:xfrm>
+            <a:off x="914400" y="4562856"/>
+            <a:ext cx="438912" cy="438912"/>
+          </a:xfrm>
+          <a:prstGeom prst="ellipse">
+            <a:avLst/>
+          </a:prstGeom>
+          <a:solidFill>
+            <a:srgbClr val="9B7EF7"/>
+          </a:solidFill>
+          <a:ln/>
+        </p:spPr>
+        <p:txBody>
+          <a:bodyPr/>
+          <a:lstStyle/>
+          <a:p>
+            <a:endParaRPr lang="ro-RO"/>
+          </a:p>
+        </p:txBody>
+      </p:sp>
+      <p:sp>
+        <p:nvSpPr>
+          <p:cNvPr id="21" name="Text 19"/>
+          <p:cNvSpPr/>
+          <p:nvPr/>
+        </p:nvSpPr>
+        <p:spPr>
+          <a:xfrm>
+            <a:off x="914400" y="4562856"/>
+            <a:ext cx="438912" cy="438912"/>
+          </a:xfrm>
+          <a:prstGeom prst="rect">
+            <a:avLst/>
+          </a:prstGeom>
+          <a:noFill/>
+          <a:ln/>
+        </p:spPr>
+        <p:txBody>
+          <a:bodyPr wrap="square" lIns="0" tIns="0" rIns="0" bIns="0" rtlCol="0" anchor="ctr"/>
+          <a:lstStyle/>
+          <a:p>
+            <a:pPr marL="0" indent="0" algn="ctr">
+              <a:buNone/>
+            </a:pPr>
+            <a:r>
+              <a:rPr lang="en-US" sz="1400" b="1" dirty="0">
+                <a:solidFill>
+                  <a:srgbClr val="11121A"/>
+                </a:solidFill>
+                <a:latin typeface="Palatino Linotype" pitchFamily="34" charset="0"/>
+                <a:ea typeface="Palatino Linotype" pitchFamily="34" charset="-122"/>
+                <a:cs typeface="Palatino Linotype" pitchFamily="34" charset="-120"/>
+              </a:rPr>
+              <a:t>4</a:t>
+            </a:r>
+            <a:endParaRPr lang="en-US" sz="1400" dirty="0"/>
+          </a:p>
+        </p:txBody>
+      </p:sp>
+      <p:sp>
+        <p:nvSpPr>
+          <p:cNvPr id="22" name="Text 20"/>
+          <p:cNvSpPr/>
+          <p:nvPr/>
+        </p:nvSpPr>
+        <p:spPr>
+          <a:xfrm>
+            <a:off x="1600200" y="4434840"/>
+            <a:ext cx="9692640" cy="347472"/>
+          </a:xfrm>
+          <a:prstGeom prst="rect">
+            <a:avLst/>
+          </a:prstGeom>
+          <a:noFill/>
+          <a:ln/>
+        </p:spPr>
+        <p:txBody>
+          <a:bodyPr wrap="square" lIns="0" tIns="0" rIns="0" bIns="0" rtlCol="0" anchor="ctr"/>
+          <a:lstStyle/>
+          <a:p>
+            <a:pPr marL="0" indent="0">
+              <a:buNone/>
+            </a:pPr>
+            <a:r>
+              <a:rPr lang="en-US" sz="1450" b="1" dirty="0">
+                <a:solidFill>
+                  <a:srgbClr val="9B7EF7"/>
+                </a:solidFill>
+                <a:latin typeface="Palatino Linotype" pitchFamily="34" charset="0"/>
+                <a:ea typeface="Palatino Linotype" pitchFamily="34" charset="-122"/>
+                <a:cs typeface="Palatino Linotype" pitchFamily="34" charset="-120"/>
+              </a:rPr>
+              <a:t>Spuneți „nu a fost identificat”, nu „nu există”.</a:t>
+            </a:r>
+            <a:endParaRPr lang="en-US" sz="1450" dirty="0"/>
+          </a:p>
+        </p:txBody>
+      </p:sp>
+      <p:sp>
+        <p:nvSpPr>
+          <p:cNvPr id="23" name="Text 21"/>
+          <p:cNvSpPr/>
+          <p:nvPr/>
+        </p:nvSpPr>
+        <p:spPr>
+          <a:xfrm>
+            <a:off x="1600200" y="4782312"/>
+            <a:ext cx="9692640" cy="365760"/>
+          </a:xfrm>
+          <a:prstGeom prst="rect">
+            <a:avLst/>
+          </a:prstGeom>
+          <a:noFill/>
+          <a:ln/>
+        </p:spPr>
+        <p:txBody>
+          <a:bodyPr wrap="square" lIns="0" tIns="0" rIns="0" bIns="0" rtlCol="0" anchor="ctr"/>
+          <a:lstStyle/>
+          <a:p>
+            <a:pPr marL="0" indent="0">
+              <a:buNone/>
+            </a:pPr>
+            <a:r>
+              <a:rPr lang="en-US" sz="1150" dirty="0">
+                <a:solidFill>
+                  <a:srgbClr val="FFFFFF"/>
+                </a:solidFill>
+                <a:latin typeface="Palatino Linotype" pitchFamily="34" charset="0"/>
+                <a:ea typeface="Palatino Linotype" pitchFamily="34" charset="-122"/>
+                <a:cs typeface="Palatino Linotype" pitchFamily="34" charset="-120"/>
+              </a:rPr>
+              <a:t>Ca la Hassall: un rezultat de laborator negativ a fost citit ca dovadă a absenței.</a:t>
+            </a:r>
+            <a:endParaRPr lang="en-US" sz="1150" dirty="0"/>
+          </a:p>
+        </p:txBody>
+      </p:sp>
+      <p:sp>
+        <p:nvSpPr>
+          <p:cNvPr id="24" name="Shape 22"/>
+          <p:cNvSpPr/>
+          <p:nvPr/>
+        </p:nvSpPr>
+        <p:spPr>
+          <a:xfrm>
+            <a:off x="594360" y="5276088"/>
+            <a:ext cx="10972800" cy="786384"/>
+          </a:xfrm>
+          <a:prstGeom prst="roundRect">
+            <a:avLst>
+              <a:gd name="adj" fmla="val 10465"/>
+            </a:avLst>
+          </a:prstGeom>
+          <a:solidFill>
+            <a:srgbClr val="2A2438"/>
+          </a:solidFill>
+          <a:ln w="12700">
+            <a:solidFill>
+              <a:srgbClr val="2A2438"/>
+            </a:solidFill>
+            <a:prstDash val="solid"/>
+          </a:ln>
+        </p:spPr>
+        <p:txBody>
+          <a:bodyPr/>
+          <a:lstStyle/>
+          <a:p>
+            <a:endParaRPr lang="ro-RO"/>
+          </a:p>
+        </p:txBody>
+      </p:sp>
+      <p:sp>
+        <p:nvSpPr>
+          <p:cNvPr id="25" name="Shape 23"/>
+          <p:cNvSpPr/>
+          <p:nvPr/>
+        </p:nvSpPr>
+        <p:spPr>
+          <a:xfrm>
+            <a:off x="914400" y="5458968"/>
+            <a:ext cx="438912" cy="438912"/>
+          </a:xfrm>
+          <a:prstGeom prst="ellipse">
+            <a:avLst/>
+          </a:prstGeom>
+          <a:solidFill>
+            <a:srgbClr val="FF8A3D"/>
+          </a:solidFill>
+          <a:ln/>
+        </p:spPr>
+        <p:txBody>
+          <a:bodyPr/>
+          <a:lstStyle/>
+          <a:p>
+            <a:endParaRPr lang="ro-RO"/>
+          </a:p>
+        </p:txBody>
+      </p:sp>
+      <p:sp>
+        <p:nvSpPr>
+          <p:cNvPr id="26" name="Text 24"/>
+          <p:cNvSpPr/>
+          <p:nvPr/>
+        </p:nvSpPr>
+        <p:spPr>
+          <a:xfrm>
+            <a:off x="914400" y="5458968"/>
+            <a:ext cx="438912" cy="438912"/>
+          </a:xfrm>
+          <a:prstGeom prst="rect">
+            <a:avLst/>
+          </a:prstGeom>
+          <a:noFill/>
+          <a:ln/>
+        </p:spPr>
+        <p:txBody>
+          <a:bodyPr wrap="square" lIns="0" tIns="0" rIns="0" bIns="0" rtlCol="0" anchor="ctr"/>
+          <a:lstStyle/>
+          <a:p>
+            <a:pPr marL="0" indent="0" algn="ctr">
+              <a:buNone/>
+            </a:pPr>
+            <a:r>
+              <a:rPr lang="en-US" sz="1400" b="1" dirty="0">
+                <a:solidFill>
+                  <a:srgbClr val="11121A"/>
+                </a:solidFill>
+                <a:latin typeface="Palatino Linotype" pitchFamily="34" charset="0"/>
+                <a:ea typeface="Palatino Linotype" pitchFamily="34" charset="-122"/>
+                <a:cs typeface="Palatino Linotype" pitchFamily="34" charset="-120"/>
+              </a:rPr>
+              <a:t>5</a:t>
+            </a:r>
+            <a:endParaRPr lang="en-US" sz="1400" dirty="0"/>
+          </a:p>
+        </p:txBody>
+      </p:sp>
+      <p:sp>
+        <p:nvSpPr>
+          <p:cNvPr id="27" name="Text 25"/>
+          <p:cNvSpPr/>
+          <p:nvPr/>
+        </p:nvSpPr>
+        <p:spPr>
+          <a:xfrm>
+            <a:off x="1600200" y="5330952"/>
+            <a:ext cx="9692640" cy="347472"/>
+          </a:xfrm>
+          <a:prstGeom prst="rect">
+            <a:avLst/>
+          </a:prstGeom>
+          <a:noFill/>
+          <a:ln/>
+        </p:spPr>
+        <p:txBody>
+          <a:bodyPr wrap="square" lIns="0" tIns="0" rIns="0" bIns="0" rtlCol="0" anchor="ctr"/>
+          <a:lstStyle/>
+          <a:p>
+            <a:pPr marL="0" indent="0">
+              <a:buNone/>
+            </a:pPr>
+            <a:r>
+              <a:rPr lang="en-US" sz="1450" b="1" dirty="0">
+                <a:solidFill>
+                  <a:srgbClr val="FF8A3D"/>
+                </a:solidFill>
+                <a:latin typeface="Palatino Linotype" pitchFamily="34" charset="0"/>
+                <a:ea typeface="Palatino Linotype" pitchFamily="34" charset="-122"/>
+                <a:cs typeface="Palatino Linotype" pitchFamily="34" charset="-120"/>
+              </a:rPr>
+              <a:t>Nu puteți verifica tot. Verificați ce schimbă o decizie.</a:t>
+            </a:r>
+            <a:endParaRPr lang="en-US" sz="1450" dirty="0"/>
+          </a:p>
+        </p:txBody>
+      </p:sp>
+      <p:sp>
+        <p:nvSpPr>
+          <p:cNvPr id="28" name="Text 26"/>
+          <p:cNvSpPr/>
+          <p:nvPr/>
+        </p:nvSpPr>
+        <p:spPr>
+          <a:xfrm>
+            <a:off x="1600200" y="5678424"/>
+            <a:ext cx="9692640" cy="365760"/>
+          </a:xfrm>
+          <a:prstGeom prst="rect">
+            <a:avLst/>
+          </a:prstGeom>
+          <a:noFill/>
+          <a:ln/>
+        </p:spPr>
+        <p:txBody>
+          <a:bodyPr wrap="square" lIns="0" tIns="0" rIns="0" bIns="0" rtlCol="0" anchor="ctr"/>
+          <a:lstStyle/>
+          <a:p>
+            <a:pPr marL="0" indent="0">
+              <a:buNone/>
+            </a:pPr>
+            <a:r>
+              <a:rPr lang="en-US" sz="1150" dirty="0">
+                <a:solidFill>
+                  <a:srgbClr val="FFFFFF"/>
+                </a:solidFill>
+                <a:latin typeface="Palatino Linotype" pitchFamily="34" charset="0"/>
+                <a:ea typeface="Palatino Linotype" pitchFamily="34" charset="-122"/>
+                <a:cs typeface="Palatino Linotype" pitchFamily="34" charset="-120"/>
+              </a:rPr>
+              <a:t>Nu veți verifica paginația unui volum vechi. Veți putea întreba întotdeauna care e numitorul unei rate.</a:t>
+            </a:r>
+            <a:endParaRPr lang="en-US" sz="1150" dirty="0"/>
+          </a:p>
+        </p:txBody>
+      </p:sp>
+      <p:sp>
+        <p:nvSpPr>
+          <p:cNvPr id="29" name="Text 27"/>
+          <p:cNvSpPr/>
+          <p:nvPr/>
+        </p:nvSpPr>
+        <p:spPr>
+          <a:xfrm>
+            <a:off x="594360" y="6236208"/>
+            <a:ext cx="10972800" cy="320040"/>
+          </a:xfrm>
+          <a:prstGeom prst="rect">
+            <a:avLst/>
+          </a:prstGeom>
+          <a:noFill/>
+          <a:ln/>
+        </p:spPr>
+        <p:txBody>
+          <a:bodyPr wrap="square" lIns="0" tIns="0" rIns="0" bIns="0" rtlCol="0" anchor="ctr"/>
+          <a:lstStyle/>
+          <a:p>
+            <a:pPr marL="0" indent="0">
+              <a:buNone/>
+            </a:pPr>
+            <a:r>
+              <a:rPr lang="en-US" sz="1200" i="1" dirty="0">
+                <a:solidFill>
+                  <a:srgbClr val="959BB0"/>
+                </a:solidFill>
+                <a:latin typeface="Palatino Linotype" pitchFamily="34" charset="0"/>
+                <a:ea typeface="Palatino Linotype" pitchFamily="34" charset="-122"/>
+                <a:cs typeface="Palatino Linotype" pitchFamily="34" charset="-120"/>
+              </a:rPr>
+              <a:t>Regula 5 nu se deduce din datele de mai sus. Se deduce din experiența pregătirii acestei sesiuni.</a:t>
+            </a:r>
+            <a:endParaRPr lang="en-US" sz="1200" dirty="0"/>
+          </a:p>
+        </p:txBody>
+      </p:sp>
+    </p:spTree>
+  </p:cSld>
+  <p:clrMapOvr>
+    <a:masterClrMapping/>
+  </p:clrMapOvr>
+</p:sld>
+</file>
+
+<file path=ppt/slides/slide49.xml><?xml version="1.0" encoding="utf-8"?>
+<p:sld xmlns:a="http://schemas.openxmlformats.org/drawingml/2006/main" xmlns:r="http://schemas.openxmlformats.org/officeDocument/2006/relationships" xmlns:p="http://schemas.openxmlformats.org/presentationml/2006/main">
+  <p:cSld name="Slide 50">
+    <p:bg>
+      <p:bgPr>
+        <a:solidFill>
+          <a:srgbClr val="F6F5F2"/>
+        </a:solidFill>
+        <a:effectLst/>
+      </p:bgPr>
+    </p:bg>
+    <p:spTree>
+      <p:nvGrpSpPr>
+        <p:cNvPr id="1" name=""/>
+        <p:cNvGrpSpPr/>
+        <p:nvPr/>
+      </p:nvGrpSpPr>
+      <p:grpSpPr>
+        <a:xfrm>
+          <a:off x="0" y="0"/>
+          <a:ext cx="0" cy="0"/>
+          <a:chOff x="0" y="0"/>
+          <a:chExt cx="0" cy="0"/>
+        </a:xfrm>
+      </p:grpSpPr>
+      <p:sp>
+        <p:nvSpPr>
+          <p:cNvPr id="2" name="Text 0"/>
+          <p:cNvSpPr/>
+          <p:nvPr/>
+        </p:nvSpPr>
+        <p:spPr>
+          <a:xfrm>
+            <a:off x="594360" y="365760"/>
+            <a:ext cx="8229600" cy="310896"/>
+          </a:xfrm>
+          <a:prstGeom prst="rect">
+            <a:avLst/>
+          </a:prstGeom>
+          <a:noFill/>
+          <a:ln/>
+        </p:spPr>
+        <p:txBody>
+          <a:bodyPr wrap="square" lIns="0" tIns="0" rIns="0" bIns="0" rtlCol="0" anchor="ctr"/>
+          <a:lstStyle/>
+          <a:p>
+            <a:pPr marL="0" indent="0">
+              <a:buNone/>
+            </a:pPr>
+            <a:r>
+              <a:rPr lang="en-US" sz="1150" b="1" kern="0" spc="300" dirty="0">
+                <a:solidFill>
+                  <a:srgbClr val="FF4757"/>
+                </a:solidFill>
+                <a:latin typeface="Palatino Linotype" pitchFamily="34" charset="0"/>
+                <a:ea typeface="Palatino Linotype" pitchFamily="34" charset="-122"/>
+                <a:cs typeface="Palatino Linotype" pitchFamily="34" charset="-120"/>
+              </a:rPr>
+              <a:t>VERIFICABIL</a:t>
+            </a:r>
+            <a:endParaRPr lang="en-US" sz="1150" dirty="0"/>
+          </a:p>
+        </p:txBody>
+      </p:sp>
+      <p:sp>
+        <p:nvSpPr>
+          <p:cNvPr id="3" name="Text 1"/>
+          <p:cNvSpPr/>
+          <p:nvPr/>
+        </p:nvSpPr>
+        <p:spPr>
+          <a:xfrm>
+            <a:off x="594360" y="694944"/>
+            <a:ext cx="10972800" cy="960120"/>
+          </a:xfrm>
+          <a:prstGeom prst="rect">
+            <a:avLst/>
+          </a:prstGeom>
+          <a:noFill/>
+          <a:ln/>
+        </p:spPr>
+        <p:txBody>
+          <a:bodyPr wrap="square" lIns="0" tIns="0" rIns="0" bIns="0" rtlCol="0" anchor="t"/>
+          <a:lstStyle/>
+          <a:p>
+            <a:pPr marL="0" indent="0">
+              <a:buNone/>
+            </a:pPr>
+            <a:r>
+              <a:rPr lang="en-US" sz="3100" b="1" dirty="0">
+                <a:solidFill>
+                  <a:srgbClr val="11121A"/>
+                </a:solidFill>
+                <a:latin typeface="Palatino Linotype" pitchFamily="34" charset="0"/>
+                <a:ea typeface="Palatino Linotype" pitchFamily="34" charset="-122"/>
+                <a:cs typeface="Palatino Linotype" pitchFamily="34" charset="-120"/>
+              </a:rPr>
+              <a:t>Sursele acestei sesiuni</a:t>
+            </a:r>
+            <a:endParaRPr lang="en-US" sz="3100" dirty="0"/>
+          </a:p>
+        </p:txBody>
+      </p:sp>
+      <p:sp>
+        <p:nvSpPr>
+          <p:cNvPr id="4" name="Text 2"/>
+          <p:cNvSpPr/>
+          <p:nvPr/>
+        </p:nvSpPr>
+        <p:spPr>
+          <a:xfrm>
+            <a:off x="594360" y="1645920"/>
+            <a:ext cx="10972800" cy="310896"/>
+          </a:xfrm>
+          <a:prstGeom prst="rect">
+            <a:avLst/>
+          </a:prstGeom>
+          <a:noFill/>
+          <a:ln/>
+        </p:spPr>
+        <p:txBody>
+          <a:bodyPr wrap="square" lIns="0" tIns="0" rIns="0" bIns="0" rtlCol="0" anchor="ctr"/>
+          <a:lstStyle/>
+          <a:p>
+            <a:pPr marL="0" indent="0">
+              <a:buNone/>
+            </a:pPr>
+            <a:r>
+              <a:rPr lang="en-US" sz="1200" i="1" dirty="0">
+                <a:solidFill>
+                  <a:srgbClr val="585A64"/>
+                </a:solidFill>
+                <a:latin typeface="Palatino Linotype" pitchFamily="34" charset="0"/>
+                <a:ea typeface="Palatino Linotype" pitchFamily="34" charset="-122"/>
+                <a:cs typeface="Palatino Linotype" pitchFamily="34" charset="-120"/>
+              </a:rPr>
+              <a:t>Fiecare cifră are o afirmație în registrul public al surselor, cu pagina și data verificării.</a:t>
+            </a:r>
+            <a:endParaRPr lang="en-US" sz="1200" dirty="0"/>
+          </a:p>
+        </p:txBody>
+      </p:sp>
+      <p:sp>
+        <p:nvSpPr>
+          <p:cNvPr id="5" name="Shape 3"/>
+          <p:cNvSpPr/>
+          <p:nvPr/>
+        </p:nvSpPr>
+        <p:spPr>
+          <a:xfrm>
+            <a:off x="594360" y="2057400"/>
+            <a:ext cx="5349240" cy="3931920"/>
+          </a:xfrm>
+          <a:prstGeom prst="roundRect">
+            <a:avLst>
+              <a:gd name="adj" fmla="val 2093"/>
+            </a:avLst>
+          </a:prstGeom>
+          <a:solidFill>
+            <a:srgbClr val="ECEAE4"/>
+          </a:solidFill>
+          <a:ln w="12700">
+            <a:solidFill>
+              <a:srgbClr val="ECEAE4"/>
+            </a:solidFill>
+            <a:prstDash val="solid"/>
+          </a:ln>
+        </p:spPr>
+        <p:txBody>
+          <a:bodyPr/>
+          <a:lstStyle/>
+          <a:p>
+            <a:endParaRPr lang="ro-RO"/>
+          </a:p>
+        </p:txBody>
+      </p:sp>
+      <p:sp>
+        <p:nvSpPr>
+          <p:cNvPr id="6" name="Text 4"/>
+          <p:cNvSpPr/>
+          <p:nvPr/>
+        </p:nvSpPr>
+        <p:spPr>
+          <a:xfrm>
+            <a:off x="914400" y="2194560"/>
+            <a:ext cx="4709160" cy="292608"/>
+          </a:xfrm>
+          <a:prstGeom prst="rect">
+            <a:avLst/>
+          </a:prstGeom>
+          <a:noFill/>
+          <a:ln/>
+        </p:spPr>
+        <p:txBody>
+          <a:bodyPr wrap="square" lIns="0" tIns="0" rIns="0" bIns="0" rtlCol="0" anchor="ctr"/>
+          <a:lstStyle/>
+          <a:p>
+            <a:pPr marL="0" indent="0">
+              <a:buNone/>
+            </a:pPr>
+            <a:r>
+              <a:rPr lang="en-US" sz="1350" b="1" dirty="0">
+                <a:solidFill>
+                  <a:srgbClr val="4A2D8C"/>
+                </a:solidFill>
+                <a:latin typeface="Palatino Linotype" pitchFamily="34" charset="0"/>
+                <a:ea typeface="Palatino Linotype" pitchFamily="34" charset="-122"/>
+                <a:cs typeface="Palatino Linotype" pitchFamily="34" charset="-120"/>
+              </a:rPr>
+              <a:t>1854 — surse primare, integral pe archive.org</a:t>
+            </a:r>
+            <a:endParaRPr lang="en-US" sz="1350" dirty="0"/>
+          </a:p>
+        </p:txBody>
+      </p:sp>
+      <p:sp>
+        <p:nvSpPr>
+          <p:cNvPr id="7" name="Text 5"/>
+          <p:cNvSpPr/>
+          <p:nvPr/>
+        </p:nvSpPr>
+        <p:spPr>
+          <a:xfrm>
+            <a:off x="1051560" y="2560320"/>
+            <a:ext cx="4663440" cy="3291840"/>
+          </a:xfrm>
+          <a:prstGeom prst="rect">
+            <a:avLst/>
+          </a:prstGeom>
+          <a:noFill/>
+          <a:ln/>
+        </p:spPr>
+        <p:txBody>
+          <a:bodyPr wrap="square" lIns="0" tIns="0" rIns="0" bIns="0" rtlCol="0" anchor="t"/>
+          <a:lstStyle/>
+          <a:p>
+            <a:pPr marL="0" indent="0">
+              <a:spcAft>
+                <a:spcPts val="400"/>
+              </a:spcAft>
+              <a:buNone/>
+            </a:pPr>
+            <a:r>
+              <a:rPr lang="en-US" sz="900" dirty="0">
+                <a:solidFill>
+                  <a:srgbClr val="11121A"/>
+                </a:solidFill>
+                <a:latin typeface="Palatino Linotype" pitchFamily="34" charset="0"/>
+                <a:ea typeface="Palatino Linotype" pitchFamily="34" charset="-122"/>
+                <a:cs typeface="Palatino Linotype" pitchFamily="34" charset="-120"/>
+              </a:rPr>
+              <a:t>[1] Snow J. On the Mode of Communication of Cholera, ed. 2. Londra: Churchill, 1855.</a:t>
+            </a:r>
+            <a:endParaRPr lang="en-US" sz="900" dirty="0"/>
+          </a:p>
+          <a:p>
+            <a:pPr marL="0" indent="0">
+              <a:spcAft>
+                <a:spcPts val="400"/>
+              </a:spcAft>
+              <a:buNone/>
+            </a:pPr>
+            <a:r>
+              <a:rPr lang="en-US" sz="900" dirty="0">
+                <a:solidFill>
+                  <a:srgbClr val="11121A"/>
+                </a:solidFill>
+                <a:latin typeface="Palatino Linotype" pitchFamily="34" charset="0"/>
+                <a:ea typeface="Palatino Linotype" pitchFamily="34" charset="-122"/>
+                <a:cs typeface="Palatino Linotype" pitchFamily="34" charset="-120"/>
+              </a:rPr>
+              <a:t>[2] Cholera Inquiry Committee. Report on the Cholera Outbreak in the Parish of St. James, Westminster. Londra, 1855.</a:t>
+            </a:r>
+            <a:endParaRPr lang="en-US" sz="900" dirty="0"/>
+          </a:p>
+          <a:p>
+            <a:pPr marL="0" indent="0">
+              <a:spcAft>
+                <a:spcPts val="400"/>
+              </a:spcAft>
+              <a:buNone/>
+            </a:pPr>
+            <a:r>
+              <a:rPr lang="en-US" sz="900" dirty="0">
+                <a:solidFill>
+                  <a:srgbClr val="11121A"/>
+                </a:solidFill>
+                <a:latin typeface="Palatino Linotype" pitchFamily="34" charset="0"/>
+                <a:ea typeface="Palatino Linotype" pitchFamily="34" charset="-122"/>
+                <a:cs typeface="Palatino Linotype" pitchFamily="34" charset="-120"/>
+              </a:rPr>
+              <a:t>[3] General Board of Health. Report of the Committee for Scientific Inquiries… Londra, 1855.</a:t>
+            </a:r>
+            <a:endParaRPr lang="en-US" sz="900" dirty="0"/>
+          </a:p>
+          <a:p>
+            <a:pPr marL="0" indent="0">
+              <a:spcAft>
+                <a:spcPts val="400"/>
+              </a:spcAft>
+              <a:buNone/>
+            </a:pPr>
+            <a:r>
+              <a:rPr lang="en-US" sz="900" dirty="0">
+                <a:solidFill>
+                  <a:srgbClr val="11121A"/>
+                </a:solidFill>
+                <a:latin typeface="Palatino Linotype" pitchFamily="34" charset="0"/>
+                <a:ea typeface="Palatino Linotype" pitchFamily="34" charset="-122"/>
+                <a:cs typeface="Palatino Linotype" pitchFamily="34" charset="-120"/>
+              </a:rPr>
+              <a:t>[4] Tulchinsky TH. John Snow, Cholera, the Broad Street Pump; Waterborne Diseases Then and Now. În: Case Studies in Public Health. Academic Press, 2018, p. 77–99. DOI: 10.1016/B978-0-12-804571-8.00017-2</a:t>
+            </a:r>
+            <a:endParaRPr lang="en-US" sz="900" dirty="0"/>
+          </a:p>
+          <a:p>
+            <a:pPr marL="0" indent="0">
+              <a:spcAft>
+                <a:spcPts val="400"/>
+              </a:spcAft>
+              <a:buNone/>
+            </a:pPr>
+            <a:r>
+              <a:rPr lang="en-US" sz="900" dirty="0">
+                <a:solidFill>
+                  <a:srgbClr val="11121A"/>
+                </a:solidFill>
+                <a:latin typeface="Palatino Linotype" pitchFamily="34" charset="0"/>
+                <a:ea typeface="Palatino Linotype" pitchFamily="34" charset="-122"/>
+                <a:cs typeface="Palatino Linotype" pitchFamily="34" charset="-120"/>
+              </a:rPr>
+              <a:t>[5] Brody H et al. Lancet. 2000;356(9223):64–68. DOI: 10.1016/S0140-6736(00)02442-9</a:t>
+            </a:r>
+            <a:endParaRPr lang="en-US" sz="900" dirty="0"/>
+          </a:p>
+          <a:p>
+            <a:pPr marL="0" indent="0">
+              <a:spcAft>
+                <a:spcPts val="400"/>
+              </a:spcAft>
+              <a:buNone/>
+            </a:pPr>
+            <a:r>
+              <a:rPr lang="en-US" sz="900" dirty="0">
+                <a:solidFill>
+                  <a:srgbClr val="11121A"/>
+                </a:solidFill>
+                <a:latin typeface="Palatino Linotype" pitchFamily="34" charset="0"/>
+                <a:ea typeface="Palatino Linotype" pitchFamily="34" charset="-122"/>
+                <a:cs typeface="Palatino Linotype" pitchFamily="34" charset="-120"/>
+              </a:rPr>
+              <a:t>[6] Paneth N et al. Am J Public Health. 1998;88(10):1545–1553. DOI: 10.2105/ajph.88.10.1545</a:t>
+            </a:r>
+            <a:endParaRPr lang="en-US" sz="900" dirty="0"/>
+          </a:p>
+          <a:p>
+            <a:pPr marL="0" indent="0">
+              <a:spcAft>
+                <a:spcPts val="400"/>
+              </a:spcAft>
+              <a:buNone/>
+            </a:pPr>
+            <a:r>
+              <a:rPr lang="en-US" sz="900" dirty="0">
+                <a:solidFill>
+                  <a:srgbClr val="11121A"/>
+                </a:solidFill>
+                <a:latin typeface="Palatino Linotype" pitchFamily="34" charset="0"/>
+                <a:ea typeface="Palatino Linotype" pitchFamily="34" charset="-122"/>
+                <a:cs typeface="Palatino Linotype" pitchFamily="34" charset="-120"/>
+              </a:rPr>
+              <a:t>[7] Vandenbroucke JP et al. Am J Epidemiol. 1991;133(10):967–973. DOI: 10.1093/oxfordjournals.aje.a115816</a:t>
+            </a:r>
+            <a:endParaRPr lang="en-US" sz="900" dirty="0"/>
+          </a:p>
+          <a:p>
+            <a:pPr marL="0" indent="0">
+              <a:spcAft>
+                <a:spcPts val="400"/>
+              </a:spcAft>
+              <a:buNone/>
+            </a:pPr>
+            <a:r>
+              <a:rPr lang="en-US" sz="900" dirty="0">
+                <a:solidFill>
+                  <a:srgbClr val="11121A"/>
+                </a:solidFill>
+                <a:latin typeface="Palatino Linotype" pitchFamily="34" charset="0"/>
+                <a:ea typeface="Palatino Linotype" pitchFamily="34" charset="-122"/>
+                <a:cs typeface="Palatino Linotype" pitchFamily="34" charset="-120"/>
+              </a:rPr>
+              <a:t>[8] Vinten-Johansen P et al. Cholera, Chloroform, and the Science of Medicine: A Life of John Snow. OUP, 2003.</a:t>
+            </a:r>
+            <a:endParaRPr lang="en-US" sz="900" dirty="0"/>
+          </a:p>
+          <a:p>
+            <a:pPr marL="0" indent="0">
+              <a:spcAft>
+                <a:spcPts val="400"/>
+              </a:spcAft>
+              <a:buNone/>
+            </a:pPr>
+            <a:r>
+              <a:rPr lang="en-US" sz="900" dirty="0">
+                <a:solidFill>
+                  <a:srgbClr val="11121A"/>
+                </a:solidFill>
+                <a:latin typeface="Palatino Linotype" pitchFamily="34" charset="0"/>
+                <a:ea typeface="Palatino Linotype" pitchFamily="34" charset="-122"/>
+                <a:cs typeface="Palatino Linotype" pitchFamily="34" charset="-120"/>
+              </a:rPr>
+              <a:t>[9] Whitehead H. The Broad Street Pump. Macmillan’s Magazine, dec. 1865;13:113–122.</a:t>
+            </a:r>
+            <a:endParaRPr lang="en-US" sz="900" dirty="0"/>
+          </a:p>
+          <a:p>
+            <a:pPr marL="0" indent="0">
+              <a:spcAft>
+                <a:spcPts val="400"/>
+              </a:spcAft>
+              <a:buNone/>
+            </a:pPr>
+            <a:r>
+              <a:rPr lang="en-US" sz="900" dirty="0">
+                <a:solidFill>
+                  <a:srgbClr val="11121A"/>
+                </a:solidFill>
+                <a:latin typeface="Palatino Linotype" pitchFamily="34" charset="0"/>
+                <a:ea typeface="Palatino Linotype" pitchFamily="34" charset="-122"/>
+                <a:cs typeface="Palatino Linotype" pitchFamily="34" charset="-120"/>
+              </a:rPr>
+              <a:t>[10] Cameron D, Jones IG. Int J Epidemiol. 1983;12(4):393–396. DOI: 10.1093/ije/12.4.393</a:t>
+            </a:r>
+            <a:endParaRPr lang="en-US" sz="900" dirty="0"/>
+          </a:p>
+          <a:p>
+            <a:pPr marL="0" indent="0">
+              <a:spcAft>
+                <a:spcPts val="400"/>
+              </a:spcAft>
+              <a:buNone/>
+            </a:pPr>
+            <a:r>
+              <a:rPr lang="en-US" sz="900" dirty="0">
+                <a:solidFill>
+                  <a:srgbClr val="11121A"/>
+                </a:solidFill>
+                <a:latin typeface="Palatino Linotype" pitchFamily="34" charset="0"/>
+                <a:ea typeface="Palatino Linotype" pitchFamily="34" charset="-122"/>
+                <a:cs typeface="Palatino Linotype" pitchFamily="34" charset="-120"/>
+              </a:rPr>
+              <a:t>[11] Eyler JM. Soz Praventivmed. 2001;46(4):225–232. DOI: 10.1007/BF01593177</a:t>
+            </a:r>
+            <a:endParaRPr lang="en-US" sz="900" dirty="0"/>
+          </a:p>
+          <a:p>
+            <a:pPr marL="0" indent="0">
+              <a:spcAft>
+                <a:spcPts val="400"/>
+              </a:spcAft>
+              <a:buNone/>
+            </a:pPr>
+            <a:r>
+              <a:rPr lang="en-US" sz="900" dirty="0">
+                <a:solidFill>
+                  <a:srgbClr val="11121A"/>
+                </a:solidFill>
+                <a:latin typeface="Palatino Linotype" pitchFamily="34" charset="0"/>
+                <a:ea typeface="Palatino Linotype" pitchFamily="34" charset="-122"/>
+                <a:cs typeface="Palatino Linotype" pitchFamily="34" charset="-120"/>
+              </a:rPr>
+              <a:t>[12] Chave SPW. Med Hist. 1958;2(2):92–108. DOI: 10.1017/s0025727300023504</a:t>
+            </a:r>
+            <a:endParaRPr lang="en-US" sz="900" dirty="0"/>
+          </a:p>
+          <a:p>
+            <a:pPr marL="0" indent="0">
+              <a:spcAft>
+                <a:spcPts val="400"/>
+              </a:spcAft>
+              <a:buNone/>
+            </a:pPr>
+            <a:r>
+              <a:rPr lang="en-US" sz="900" dirty="0">
+                <a:solidFill>
+                  <a:srgbClr val="11121A"/>
+                </a:solidFill>
+                <a:latin typeface="Palatino Linotype" pitchFamily="34" charset="0"/>
+                <a:ea typeface="Palatino Linotype" pitchFamily="34" charset="-122"/>
+                <a:cs typeface="Palatino Linotype" pitchFamily="34" charset="-120"/>
+              </a:rPr>
+              <a:t>[13] Ramsay MAE. Proc (Bayl Univ Med Cent). 2006;19(1):24–28.</a:t>
+            </a:r>
+            <a:endParaRPr lang="en-US" sz="900" dirty="0"/>
+          </a:p>
+        </p:txBody>
+      </p:sp>
+      <p:sp>
+        <p:nvSpPr>
+          <p:cNvPr id="8" name="Shape 6"/>
+          <p:cNvSpPr/>
+          <p:nvPr/>
+        </p:nvSpPr>
+        <p:spPr>
+          <a:xfrm>
+            <a:off x="6217920" y="2057400"/>
+            <a:ext cx="5349240" cy="3931920"/>
+          </a:xfrm>
+          <a:prstGeom prst="roundRect">
+            <a:avLst>
+              <a:gd name="adj" fmla="val 2093"/>
+            </a:avLst>
+          </a:prstGeom>
+          <a:solidFill>
+            <a:srgbClr val="ECEAE4"/>
+          </a:solidFill>
+          <a:ln w="12700">
+            <a:solidFill>
+              <a:srgbClr val="ECEAE4"/>
+            </a:solidFill>
+            <a:prstDash val="solid"/>
+          </a:ln>
+        </p:spPr>
+        <p:txBody>
+          <a:bodyPr/>
+          <a:lstStyle/>
+          <a:p>
+            <a:endParaRPr lang="ro-RO"/>
+          </a:p>
+        </p:txBody>
+      </p:sp>
+      <p:sp>
+        <p:nvSpPr>
+          <p:cNvPr id="9" name="Text 7"/>
+          <p:cNvSpPr/>
+          <p:nvPr/>
+        </p:nvSpPr>
+        <p:spPr>
+          <a:xfrm>
+            <a:off x="6537960" y="2194560"/>
+            <a:ext cx="4709160" cy="292608"/>
+          </a:xfrm>
+          <a:prstGeom prst="rect">
+            <a:avLst/>
+          </a:prstGeom>
+          <a:noFill/>
+          <a:ln/>
+        </p:spPr>
+        <p:txBody>
+          <a:bodyPr wrap="square" lIns="0" tIns="0" rIns="0" bIns="0" rtlCol="0" anchor="ctr"/>
+          <a:lstStyle/>
+          <a:p>
+            <a:pPr marL="0" indent="0">
+              <a:buNone/>
+            </a:pPr>
+            <a:r>
+              <a:rPr lang="en-US" sz="1350" b="1" dirty="0">
+                <a:solidFill>
+                  <a:srgbClr val="0E7C6B"/>
+                </a:solidFill>
+                <a:latin typeface="Palatino Linotype" pitchFamily="34" charset="0"/>
+                <a:ea typeface="Palatino Linotype" pitchFamily="34" charset="-122"/>
+                <a:cs typeface="Palatino Linotype" pitchFamily="34" charset="-120"/>
+              </a:rPr>
+              <a:t>Modern — focare, formare, genomică</a:t>
+            </a:r>
+            <a:endParaRPr lang="en-US" sz="1350" dirty="0"/>
+          </a:p>
+        </p:txBody>
+      </p:sp>
+      <p:sp>
+        <p:nvSpPr>
+          <p:cNvPr id="10" name="Text 8"/>
+          <p:cNvSpPr/>
+          <p:nvPr/>
+        </p:nvSpPr>
+        <p:spPr>
+          <a:xfrm>
+            <a:off x="6675120" y="2560320"/>
+            <a:ext cx="4663440" cy="3291840"/>
+          </a:xfrm>
+          <a:prstGeom prst="rect">
+            <a:avLst/>
+          </a:prstGeom>
+          <a:noFill/>
+          <a:ln/>
+        </p:spPr>
+        <p:txBody>
+          <a:bodyPr wrap="square" lIns="0" tIns="0" rIns="0" bIns="0" rtlCol="0" anchor="t"/>
+          <a:lstStyle/>
+          <a:p>
+            <a:pPr marL="0" indent="0">
+              <a:spcAft>
+                <a:spcPts val="400"/>
+              </a:spcAft>
+              <a:buNone/>
+            </a:pPr>
+            <a:r>
+              <a:rPr lang="en-US" sz="900" dirty="0">
+                <a:solidFill>
+                  <a:srgbClr val="11121A"/>
+                </a:solidFill>
+                <a:latin typeface="Palatino Linotype" pitchFamily="34" charset="0"/>
+                <a:ea typeface="Palatino Linotype" pitchFamily="34" charset="-122"/>
+                <a:cs typeface="Palatino Linotype" pitchFamily="34" charset="-120"/>
+              </a:rPr>
+              <a:t>[14] CDC. MMWR. 1993;42(14):258–263.</a:t>
+            </a:r>
+            <a:endParaRPr lang="en-US" sz="900" dirty="0"/>
+          </a:p>
+          <a:p>
+            <a:pPr marL="0" indent="0">
+              <a:spcAft>
+                <a:spcPts val="400"/>
+              </a:spcAft>
+              <a:buNone/>
+            </a:pPr>
+            <a:r>
+              <a:rPr lang="en-US" sz="900" dirty="0">
+                <a:solidFill>
+                  <a:srgbClr val="11121A"/>
+                </a:solidFill>
+                <a:latin typeface="Palatino Linotype" pitchFamily="34" charset="0"/>
+                <a:ea typeface="Palatino Linotype" pitchFamily="34" charset="-122"/>
+                <a:cs typeface="Palatino Linotype" pitchFamily="34" charset="-120"/>
+              </a:rPr>
+              <a:t>[15] Tuttle J et al. Epidemiol Infect. 1999;122(2):185–192. DOI: 10.1017/s0950268898001976</a:t>
+            </a:r>
+            <a:endParaRPr lang="en-US" sz="900" dirty="0"/>
+          </a:p>
+          <a:p>
+            <a:pPr marL="0" indent="0">
+              <a:spcAft>
+                <a:spcPts val="400"/>
+              </a:spcAft>
+              <a:buNone/>
+            </a:pPr>
+            <a:r>
+              <a:rPr lang="en-US" sz="900" dirty="0">
+                <a:solidFill>
+                  <a:srgbClr val="11121A"/>
+                </a:solidFill>
+                <a:latin typeface="Palatino Linotype" pitchFamily="34" charset="0"/>
+                <a:ea typeface="Palatino Linotype" pitchFamily="34" charset="-122"/>
+                <a:cs typeface="Palatino Linotype" pitchFamily="34" charset="-120"/>
+              </a:rPr>
+              <a:t>[16] Baize S et al. N Engl J Med. 2014;371(15):1418–1425. DOI: 10.1056/NEJMoa1404505</a:t>
+            </a:r>
+            <a:endParaRPr lang="en-US" sz="900" dirty="0"/>
+          </a:p>
+          <a:p>
+            <a:pPr marL="0" indent="0">
+              <a:spcAft>
+                <a:spcPts val="400"/>
+              </a:spcAft>
+              <a:buNone/>
+            </a:pPr>
+            <a:r>
+              <a:rPr lang="en-US" sz="900" dirty="0">
+                <a:solidFill>
+                  <a:srgbClr val="11121A"/>
+                </a:solidFill>
+                <a:latin typeface="Palatino Linotype" pitchFamily="34" charset="0"/>
+                <a:ea typeface="Palatino Linotype" pitchFamily="34" charset="-122"/>
+                <a:cs typeface="Palatino Linotype" pitchFamily="34" charset="-120"/>
+              </a:rPr>
+              <a:t>[17] Malyarchuk AB et al. Biochemistry (Mosc). 2022;87(3):242–258. DOI: 10.1134/S0006297922030051</a:t>
+            </a:r>
+            <a:endParaRPr lang="en-US" sz="900" dirty="0"/>
+          </a:p>
+          <a:p>
+            <a:pPr marL="0" indent="0">
+              <a:spcAft>
+                <a:spcPts val="400"/>
+              </a:spcAft>
+              <a:buNone/>
+            </a:pPr>
+            <a:r>
+              <a:rPr lang="en-US" sz="900" dirty="0">
+                <a:solidFill>
+                  <a:srgbClr val="11121A"/>
+                </a:solidFill>
+                <a:latin typeface="Palatino Linotype" pitchFamily="34" charset="0"/>
+                <a:ea typeface="Palatino Linotype" pitchFamily="34" charset="-122"/>
+                <a:cs typeface="Palatino Linotype" pitchFamily="34" charset="-120"/>
+              </a:rPr>
+              <a:t>[18] Dorman MJ et al. Proc Biol Sci. 2019;286(1900):20182025. DOI: 10.1098/rspb.2018.2025</a:t>
+            </a:r>
+            <a:endParaRPr lang="en-US" sz="900" dirty="0"/>
+          </a:p>
+          <a:p>
+            <a:pPr marL="0" indent="0">
+              <a:spcAft>
+                <a:spcPts val="400"/>
+              </a:spcAft>
+              <a:buNone/>
+            </a:pPr>
+            <a:r>
+              <a:rPr lang="en-US" sz="900" dirty="0">
+                <a:solidFill>
+                  <a:srgbClr val="11121A"/>
+                </a:solidFill>
+                <a:latin typeface="Palatino Linotype" pitchFamily="34" charset="0"/>
+                <a:ea typeface="Palatino Linotype" pitchFamily="34" charset="-122"/>
+                <a:cs typeface="Palatino Linotype" pitchFamily="34" charset="-120"/>
+              </a:rPr>
+              <a:t>[19] LPSN (DSMZ). Vibrio cholerae. Accesat la 6.10.2026.</a:t>
+            </a:r>
+            <a:endParaRPr lang="en-US" sz="900" dirty="0"/>
+          </a:p>
+          <a:p>
+            <a:pPr marL="0" indent="0">
+              <a:spcAft>
+                <a:spcPts val="400"/>
+              </a:spcAft>
+              <a:buNone/>
+            </a:pPr>
+            <a:r>
+              <a:rPr lang="en-US" sz="900" dirty="0">
+                <a:solidFill>
+                  <a:srgbClr val="11121A"/>
+                </a:solidFill>
+                <a:latin typeface="Palatino Linotype" pitchFamily="34" charset="0"/>
+                <a:ea typeface="Palatino Linotype" pitchFamily="34" charset="-122"/>
+                <a:cs typeface="Palatino Linotype" pitchFamily="34" charset="-120"/>
+              </a:rPr>
+              <a:t>[20] OMS. Zoonoses. Fact sheet, 29 iulie 2020.</a:t>
+            </a:r>
+            <a:endParaRPr lang="en-US" sz="900" dirty="0"/>
+          </a:p>
+          <a:p>
+            <a:pPr marL="0" indent="0">
+              <a:spcAft>
+                <a:spcPts val="400"/>
+              </a:spcAft>
+              <a:buNone/>
+            </a:pPr>
+            <a:r>
+              <a:rPr lang="en-US" sz="900" dirty="0">
+                <a:solidFill>
+                  <a:srgbClr val="11121A"/>
+                </a:solidFill>
+                <a:latin typeface="Palatino Linotype" pitchFamily="34" charset="0"/>
+                <a:ea typeface="Palatino Linotype" pitchFamily="34" charset="-122"/>
+                <a:cs typeface="Palatino Linotype" pitchFamily="34" charset="-120"/>
+              </a:rPr>
+              <a:t>[21] CDC. Principles of Epidemiology, ed. 3, Lecția 6. Rev. 2011.</a:t>
+            </a:r>
+            <a:endParaRPr lang="en-US" sz="900" dirty="0"/>
+          </a:p>
+          <a:p>
+            <a:pPr marL="0" indent="0">
+              <a:spcAft>
+                <a:spcPts val="400"/>
+              </a:spcAft>
+              <a:buNone/>
+            </a:pPr>
+            <a:r>
+              <a:rPr lang="en-US" sz="900" dirty="0">
+                <a:solidFill>
+                  <a:srgbClr val="11121A"/>
+                </a:solidFill>
+                <a:latin typeface="Palatino Linotype" pitchFamily="34" charset="0"/>
+                <a:ea typeface="Palatino Linotype" pitchFamily="34" charset="-122"/>
+                <a:cs typeface="Palatino Linotype" pitchFamily="34" charset="-120"/>
+              </a:rPr>
+              <a:t>[22] FEM Wiki (găzduit de ECDC), export PDF, 417 p., creat la 29.11.2022.</a:t>
+            </a:r>
+            <a:endParaRPr lang="en-US" sz="900" dirty="0"/>
+          </a:p>
+          <a:p>
+            <a:pPr marL="0" indent="0">
+              <a:spcAft>
+                <a:spcPts val="400"/>
+              </a:spcAft>
+              <a:buNone/>
+            </a:pPr>
+            <a:r>
+              <a:rPr lang="en-US" sz="900" dirty="0">
+                <a:solidFill>
+                  <a:srgbClr val="11121A"/>
+                </a:solidFill>
+                <a:latin typeface="Palatino Linotype" pitchFamily="34" charset="0"/>
+                <a:ea typeface="Palatino Linotype" pitchFamily="34" charset="-122"/>
+                <a:cs typeface="Palatino Linotype" pitchFamily="34" charset="-120"/>
+              </a:rPr>
+              <a:t>[23] Gregg MB (ed.). Field Epidemiology, ed. 3. OUP, 2008. ISBN 9780195313802.</a:t>
+            </a:r>
+            <a:endParaRPr lang="en-US" sz="900" dirty="0"/>
+          </a:p>
+          <a:p>
+            <a:pPr marL="0" indent="0">
+              <a:spcAft>
+                <a:spcPts val="400"/>
+              </a:spcAft>
+              <a:buNone/>
+            </a:pPr>
+            <a:r>
+              <a:rPr lang="en-US" sz="900" dirty="0">
+                <a:solidFill>
+                  <a:srgbClr val="11121A"/>
+                </a:solidFill>
+                <a:latin typeface="Palatino Linotype" pitchFamily="34" charset="0"/>
+                <a:ea typeface="Palatino Linotype" pitchFamily="34" charset="-122"/>
+                <a:cs typeface="Palatino Linotype" pitchFamily="34" charset="-120"/>
+              </a:rPr>
+              <a:t>[24] INSP–CNSCBT. Raport pentru anul 2024 (15 oct. 2025, 84 p.).</a:t>
+            </a:r>
+            <a:endParaRPr lang="en-US" sz="900" dirty="0"/>
+          </a:p>
+          <a:p>
+            <a:pPr marL="0" indent="0">
+              <a:spcAft>
+                <a:spcPts val="400"/>
+              </a:spcAft>
+              <a:buNone/>
+            </a:pPr>
+            <a:r>
+              <a:rPr lang="en-US" sz="900" dirty="0">
+                <a:solidFill>
+                  <a:srgbClr val="11121A"/>
+                </a:solidFill>
+                <a:latin typeface="Palatino Linotype" pitchFamily="34" charset="0"/>
+                <a:ea typeface="Palatino Linotype" pitchFamily="34" charset="-122"/>
+                <a:cs typeface="Palatino Linotype" pitchFamily="34" charset="-120"/>
+              </a:rPr>
+              <a:t>[25] OMS. Wkly Epidemiol Rec. 2026;101(35) și 101(38): holera, 2025–2026.</a:t>
+            </a:r>
+            <a:endParaRPr lang="en-US" sz="900" dirty="0"/>
+          </a:p>
+          <a:p>
+            <a:pPr marL="0" indent="0">
+              <a:spcAft>
+                <a:spcPts val="400"/>
+              </a:spcAft>
+              <a:buNone/>
+            </a:pPr>
+            <a:r>
+              <a:rPr lang="en-US" sz="900" dirty="0">
+                <a:solidFill>
+                  <a:srgbClr val="11121A"/>
+                </a:solidFill>
+                <a:latin typeface="Palatino Linotype" pitchFamily="34" charset="0"/>
+                <a:ea typeface="Palatino Linotype" pitchFamily="34" charset="-122"/>
+                <a:cs typeface="Palatino Linotype" pitchFamily="34" charset="-120"/>
+              </a:rPr>
+              <a:t>[26] OMS. Tabelul SARS (2003); Ebola 2014–2016; Origins of the 2014 Ebola epidemic (2015).</a:t>
+            </a:r>
+            <a:endParaRPr lang="en-US" sz="900" dirty="0"/>
+          </a:p>
+          <a:p>
+            <a:pPr marL="0" indent="0">
+              <a:spcAft>
+                <a:spcPts val="400"/>
+              </a:spcAft>
+              <a:buNone/>
+            </a:pPr>
+            <a:r>
+              <a:rPr lang="en-US" sz="900" dirty="0">
+                <a:solidFill>
+                  <a:srgbClr val="11121A"/>
+                </a:solidFill>
+                <a:latin typeface="Palatino Linotype" pitchFamily="34" charset="0"/>
+                <a:ea typeface="Palatino Linotype" pitchFamily="34" charset="-122"/>
+                <a:cs typeface="Palatino Linotype" pitchFamily="34" charset="-120"/>
+              </a:rPr>
+              <a:t>[27] CDC. About EIS; EIS 2025 annual update. ECDC. Siturile de formare (6.02.2026). TEPHINET.</a:t>
+            </a:r>
+            <a:endParaRPr lang="en-US" sz="900" dirty="0"/>
+          </a:p>
+          <a:p>
+            <a:pPr marL="0" indent="0">
+              <a:spcAft>
+                <a:spcPts val="400"/>
+              </a:spcAft>
+              <a:buNone/>
+            </a:pPr>
+            <a:r>
+              <a:rPr lang="en-US" sz="900" dirty="0">
+                <a:solidFill>
+                  <a:srgbClr val="11121A"/>
+                </a:solidFill>
+                <a:latin typeface="Palatino Linotype" pitchFamily="34" charset="0"/>
+                <a:ea typeface="Palatino Linotype" pitchFamily="34" charset="-122"/>
+                <a:cs typeface="Palatino Linotype" pitchFamily="34" charset="-120"/>
+              </a:rPr>
+              <a:t>[28] INS. TEMPO POP105A și SAN104A. Eurostat. hlth_rs_spec; hlth_rs_physcat.</a:t>
+            </a:r>
+            <a:endParaRPr lang="en-US" sz="900" dirty="0"/>
+          </a:p>
+          <a:p>
+            <a:pPr marL="0" indent="0">
+              <a:spcAft>
+                <a:spcPts val="400"/>
+              </a:spcAft>
+              <a:buNone/>
+            </a:pPr>
+            <a:r>
+              <a:rPr lang="en-US" sz="900" dirty="0">
+                <a:solidFill>
+                  <a:srgbClr val="11121A"/>
+                </a:solidFill>
+                <a:latin typeface="Palatino Linotype" pitchFamily="34" charset="0"/>
+                <a:ea typeface="Palatino Linotype" pitchFamily="34" charset="-122"/>
+                <a:cs typeface="Palatino Linotype" pitchFamily="34" charset="-120"/>
+              </a:rPr>
+              <a:t>[29] Directiva (UE) 2024/3019 (apele uzate urbane), art. 17.</a:t>
+            </a:r>
+            <a:endParaRPr lang="en-US" sz="900" dirty="0"/>
+          </a:p>
+        </p:txBody>
+      </p:sp>
+      <p:sp>
+        <p:nvSpPr>
+          <p:cNvPr id="11" name="Text 9"/>
+          <p:cNvSpPr/>
+          <p:nvPr/>
+        </p:nvSpPr>
+        <p:spPr>
+          <a:xfrm>
+            <a:off x="594360" y="6309360"/>
+            <a:ext cx="10972800" cy="310896"/>
+          </a:xfrm>
+          <a:prstGeom prst="rect">
+            <a:avLst/>
+          </a:prstGeom>
+          <a:noFill/>
+          <a:ln/>
+        </p:spPr>
+        <p:txBody>
+          <a:bodyPr wrap="square" lIns="0" tIns="0" rIns="0" bIns="0" rtlCol="0" anchor="ctr"/>
+          <a:lstStyle/>
+          <a:p>
+            <a:pPr marL="0" indent="0">
+              <a:buNone/>
+            </a:pPr>
+            <a:r>
+              <a:rPr lang="en-US" sz="900" i="1" dirty="0">
+                <a:solidFill>
+                  <a:srgbClr val="585A64"/>
+                </a:solidFill>
+                <a:latin typeface="Palatino Linotype" pitchFamily="34" charset="0"/>
+                <a:ea typeface="Palatino Linotype" pitchFamily="34" charset="-122"/>
+                <a:cs typeface="Palatino Linotype" pitchFamily="34" charset="-120"/>
+              </a:rPr>
+              <a:t>Ce nu s-a putut verifica este listat în caseta „Ce nu putem afirma” din notele de curs.</a:t>
+            </a:r>
+            <a:endParaRPr lang="en-US" sz="900" dirty="0"/>
           </a:p>
         </p:txBody>
       </p:sp>
@@ -33782,2025 +35673,6 @@
 </file>
 
 <file path=ppt/slides/slide50.xml><?xml version="1.0" encoding="utf-8"?>
-<p:sld xmlns:a="http://schemas.openxmlformats.org/drawingml/2006/main" xmlns:r="http://schemas.openxmlformats.org/officeDocument/2006/relationships" xmlns:p="http://schemas.openxmlformats.org/presentationml/2006/main">
-  <p:cSld name="Slide 49">
-    <p:bg>
-      <p:bgPr>
-        <a:solidFill>
-          <a:srgbClr val="11121A"/>
-        </a:solidFill>
-        <a:effectLst/>
-      </p:bgPr>
-    </p:bg>
-    <p:spTree>
-      <p:nvGrpSpPr>
-        <p:cNvPr id="1" name=""/>
-        <p:cNvGrpSpPr/>
-        <p:nvPr/>
-      </p:nvGrpSpPr>
-      <p:grpSpPr>
-        <a:xfrm>
-          <a:off x="0" y="0"/>
-          <a:ext cx="0" cy="0"/>
-          <a:chOff x="0" y="0"/>
-          <a:chExt cx="0" cy="0"/>
-        </a:xfrm>
-      </p:grpSpPr>
-      <p:sp>
-        <p:nvSpPr>
-          <p:cNvPr id="2" name="Text 0"/>
-          <p:cNvSpPr/>
-          <p:nvPr/>
-        </p:nvSpPr>
-        <p:spPr>
-          <a:xfrm>
-            <a:off x="594360" y="365760"/>
-            <a:ext cx="8229600" cy="310896"/>
-          </a:xfrm>
-          <a:prstGeom prst="rect">
-            <a:avLst/>
-          </a:prstGeom>
-          <a:noFill/>
-          <a:ln/>
-        </p:spPr>
-        <p:txBody>
-          <a:bodyPr wrap="square" lIns="0" tIns="0" rIns="0" bIns="0" rtlCol="0" anchor="ctr"/>
-          <a:lstStyle/>
-          <a:p>
-            <a:pPr marL="0" indent="0">
-              <a:buNone/>
-            </a:pPr>
-            <a:r>
-              <a:rPr lang="en-US" sz="1150" b="1" kern="0" spc="300" dirty="0">
-                <a:solidFill>
-                  <a:srgbClr val="FF4757"/>
-                </a:solidFill>
-                <a:latin typeface="Palatino Linotype" pitchFamily="34" charset="0"/>
-                <a:ea typeface="Palatino Linotype" pitchFamily="34" charset="-122"/>
-                <a:cs typeface="Palatino Linotype" pitchFamily="34" charset="-120"/>
-              </a:rPr>
-              <a:t>CINCI REGULI</a:t>
-            </a:r>
-            <a:endParaRPr lang="en-US" sz="1150" dirty="0"/>
-          </a:p>
-        </p:txBody>
-      </p:sp>
-      <p:sp>
-        <p:nvSpPr>
-          <p:cNvPr id="3" name="Text 1"/>
-          <p:cNvSpPr/>
-          <p:nvPr/>
-        </p:nvSpPr>
-        <p:spPr>
-          <a:xfrm>
-            <a:off x="594360" y="694944"/>
-            <a:ext cx="10972800" cy="960120"/>
-          </a:xfrm>
-          <a:prstGeom prst="rect">
-            <a:avLst/>
-          </a:prstGeom>
-          <a:noFill/>
-          <a:ln/>
-        </p:spPr>
-        <p:txBody>
-          <a:bodyPr wrap="square" lIns="0" tIns="0" rIns="0" bIns="0" rtlCol="0" anchor="t"/>
-          <a:lstStyle/>
-          <a:p>
-            <a:pPr marL="0" indent="0">
-              <a:buNone/>
-            </a:pPr>
-            <a:r>
-              <a:rPr lang="en-US" sz="3100" b="1" dirty="0">
-                <a:solidFill>
-                  <a:srgbClr val="FFFFFF"/>
-                </a:solidFill>
-                <a:latin typeface="Palatino Linotype" pitchFamily="34" charset="0"/>
-                <a:ea typeface="Palatino Linotype" pitchFamily="34" charset="-122"/>
-                <a:cs typeface="Palatino Linotype" pitchFamily="34" charset="-120"/>
-              </a:rPr>
-              <a:t>Ce luați cu voi</a:t>
-            </a:r>
-            <a:endParaRPr lang="en-US" sz="3100" dirty="0"/>
-          </a:p>
-        </p:txBody>
-      </p:sp>
-      <p:sp>
-        <p:nvSpPr>
-          <p:cNvPr id="4" name="Shape 2"/>
-          <p:cNvSpPr/>
-          <p:nvPr/>
-        </p:nvSpPr>
-        <p:spPr>
-          <a:xfrm>
-            <a:off x="594360" y="1691640"/>
-            <a:ext cx="10972800" cy="786384"/>
-          </a:xfrm>
-          <a:prstGeom prst="roundRect">
-            <a:avLst>
-              <a:gd name="adj" fmla="val 10465"/>
-            </a:avLst>
-          </a:prstGeom>
-          <a:solidFill>
-            <a:srgbClr val="1D1F2B"/>
-          </a:solidFill>
-          <a:ln w="12700">
-            <a:solidFill>
-              <a:srgbClr val="1D1F2B"/>
-            </a:solidFill>
-            <a:prstDash val="solid"/>
-          </a:ln>
-        </p:spPr>
-        <p:txBody>
-          <a:bodyPr/>
-          <a:lstStyle/>
-          <a:p>
-            <a:endParaRPr lang="ro-RO"/>
-          </a:p>
-        </p:txBody>
-      </p:sp>
-      <p:sp>
-        <p:nvSpPr>
-          <p:cNvPr id="5" name="Shape 3"/>
-          <p:cNvSpPr/>
-          <p:nvPr/>
-        </p:nvSpPr>
-        <p:spPr>
-          <a:xfrm>
-            <a:off x="914400" y="1874520"/>
-            <a:ext cx="438912" cy="438912"/>
-          </a:xfrm>
-          <a:prstGeom prst="ellipse">
-            <a:avLst/>
-          </a:prstGeom>
-          <a:solidFill>
-            <a:srgbClr val="FF4757"/>
-          </a:solidFill>
-          <a:ln/>
-        </p:spPr>
-        <p:txBody>
-          <a:bodyPr/>
-          <a:lstStyle/>
-          <a:p>
-            <a:endParaRPr lang="ro-RO"/>
-          </a:p>
-        </p:txBody>
-      </p:sp>
-      <p:sp>
-        <p:nvSpPr>
-          <p:cNvPr id="6" name="Text 4"/>
-          <p:cNvSpPr/>
-          <p:nvPr/>
-        </p:nvSpPr>
-        <p:spPr>
-          <a:xfrm>
-            <a:off x="914400" y="1874520"/>
-            <a:ext cx="438912" cy="438912"/>
-          </a:xfrm>
-          <a:prstGeom prst="rect">
-            <a:avLst/>
-          </a:prstGeom>
-          <a:noFill/>
-          <a:ln/>
-        </p:spPr>
-        <p:txBody>
-          <a:bodyPr wrap="square" lIns="0" tIns="0" rIns="0" bIns="0" rtlCol="0" anchor="ctr"/>
-          <a:lstStyle/>
-          <a:p>
-            <a:pPr marL="0" indent="0" algn="ctr">
-              <a:buNone/>
-            </a:pPr>
-            <a:r>
-              <a:rPr lang="en-US" sz="1400" b="1" dirty="0">
-                <a:solidFill>
-                  <a:srgbClr val="11121A"/>
-                </a:solidFill>
-                <a:latin typeface="Palatino Linotype" pitchFamily="34" charset="0"/>
-                <a:ea typeface="Palatino Linotype" pitchFamily="34" charset="-122"/>
-                <a:cs typeface="Palatino Linotype" pitchFamily="34" charset="-120"/>
-              </a:rPr>
-              <a:t>1</a:t>
-            </a:r>
-            <a:endParaRPr lang="en-US" sz="1400" dirty="0"/>
-          </a:p>
-        </p:txBody>
-      </p:sp>
-      <p:sp>
-        <p:nvSpPr>
-          <p:cNvPr id="7" name="Text 5"/>
-          <p:cNvSpPr/>
-          <p:nvPr/>
-        </p:nvSpPr>
-        <p:spPr>
-          <a:xfrm>
-            <a:off x="1600200" y="1746504"/>
-            <a:ext cx="9692640" cy="347472"/>
-          </a:xfrm>
-          <a:prstGeom prst="rect">
-            <a:avLst/>
-          </a:prstGeom>
-          <a:noFill/>
-          <a:ln/>
-        </p:spPr>
-        <p:txBody>
-          <a:bodyPr wrap="square" lIns="0" tIns="0" rIns="0" bIns="0" rtlCol="0" anchor="ctr"/>
-          <a:lstStyle/>
-          <a:p>
-            <a:pPr marL="0" indent="0">
-              <a:buNone/>
-            </a:pPr>
-            <a:r>
-              <a:rPr lang="en-US" sz="1450" b="1" dirty="0">
-                <a:solidFill>
-                  <a:srgbClr val="FF4757"/>
-                </a:solidFill>
-                <a:latin typeface="Palatino Linotype" pitchFamily="34" charset="0"/>
-                <a:ea typeface="Palatino Linotype" pitchFamily="34" charset="-122"/>
-                <a:cs typeface="Palatino Linotype" pitchFamily="34" charset="-120"/>
-              </a:rPr>
-              <a:t>Cereți numitorul — și apoi grupul de comparație.</a:t>
-            </a:r>
-            <a:endParaRPr lang="en-US" sz="1450" dirty="0"/>
-          </a:p>
-        </p:txBody>
-      </p:sp>
-      <p:sp>
-        <p:nvSpPr>
-          <p:cNvPr id="8" name="Text 6"/>
-          <p:cNvSpPr/>
-          <p:nvPr/>
-        </p:nvSpPr>
-        <p:spPr>
-          <a:xfrm>
-            <a:off x="1600200" y="2093976"/>
-            <a:ext cx="9692640" cy="365760"/>
-          </a:xfrm>
-          <a:prstGeom prst="rect">
-            <a:avLst/>
-          </a:prstGeom>
-          <a:noFill/>
-          <a:ln/>
-        </p:spPr>
-        <p:txBody>
-          <a:bodyPr wrap="square" lIns="0" tIns="0" rIns="0" bIns="0" rtlCol="0" anchor="ctr"/>
-          <a:lstStyle/>
-          <a:p>
-            <a:pPr marL="0" indent="0">
-              <a:buNone/>
-            </a:pPr>
-            <a:r>
-              <a:rPr lang="en-US" sz="1150" dirty="0">
-                <a:solidFill>
-                  <a:srgbClr val="FFFFFF"/>
-                </a:solidFill>
-                <a:latin typeface="Palatino Linotype" pitchFamily="34" charset="0"/>
-                <a:ea typeface="Palatino Linotype" pitchFamily="34" charset="-122"/>
-                <a:cs typeface="Palatino Linotype" pitchFamily="34" charset="-120"/>
-              </a:rPr>
-              <a:t>Numitorul e necesar și nu e suficient: Farr avea numitor și greșea. Ce decide este alocarea neconfundată.</a:t>
-            </a:r>
-            <a:endParaRPr lang="en-US" sz="1150" dirty="0"/>
-          </a:p>
-        </p:txBody>
-      </p:sp>
-      <p:sp>
-        <p:nvSpPr>
-          <p:cNvPr id="9" name="Shape 7"/>
-          <p:cNvSpPr/>
-          <p:nvPr/>
-        </p:nvSpPr>
-        <p:spPr>
-          <a:xfrm>
-            <a:off x="594360" y="2587752"/>
-            <a:ext cx="10972800" cy="786384"/>
-          </a:xfrm>
-          <a:prstGeom prst="roundRect">
-            <a:avLst>
-              <a:gd name="adj" fmla="val 10465"/>
-            </a:avLst>
-          </a:prstGeom>
-          <a:solidFill>
-            <a:srgbClr val="272A38"/>
-          </a:solidFill>
-          <a:ln w="12700">
-            <a:solidFill>
-              <a:srgbClr val="272A38"/>
-            </a:solidFill>
-            <a:prstDash val="solid"/>
-          </a:ln>
-        </p:spPr>
-        <p:txBody>
-          <a:bodyPr/>
-          <a:lstStyle/>
-          <a:p>
-            <a:endParaRPr lang="ro-RO"/>
-          </a:p>
-        </p:txBody>
-      </p:sp>
-      <p:sp>
-        <p:nvSpPr>
-          <p:cNvPr id="10" name="Shape 8"/>
-          <p:cNvSpPr/>
-          <p:nvPr/>
-        </p:nvSpPr>
-        <p:spPr>
-          <a:xfrm>
-            <a:off x="914400" y="2770632"/>
-            <a:ext cx="438912" cy="438912"/>
-          </a:xfrm>
-          <a:prstGeom prst="ellipse">
-            <a:avLst/>
-          </a:prstGeom>
-          <a:solidFill>
-            <a:srgbClr val="FFC24B"/>
-          </a:solidFill>
-          <a:ln/>
-        </p:spPr>
-        <p:txBody>
-          <a:bodyPr/>
-          <a:lstStyle/>
-          <a:p>
-            <a:endParaRPr lang="ro-RO"/>
-          </a:p>
-        </p:txBody>
-      </p:sp>
-      <p:sp>
-        <p:nvSpPr>
-          <p:cNvPr id="11" name="Text 9"/>
-          <p:cNvSpPr/>
-          <p:nvPr/>
-        </p:nvSpPr>
-        <p:spPr>
-          <a:xfrm>
-            <a:off x="914400" y="2770632"/>
-            <a:ext cx="438912" cy="438912"/>
-          </a:xfrm>
-          <a:prstGeom prst="rect">
-            <a:avLst/>
-          </a:prstGeom>
-          <a:noFill/>
-          <a:ln/>
-        </p:spPr>
-        <p:txBody>
-          <a:bodyPr wrap="square" lIns="0" tIns="0" rIns="0" bIns="0" rtlCol="0" anchor="ctr"/>
-          <a:lstStyle/>
-          <a:p>
-            <a:pPr marL="0" indent="0" algn="ctr">
-              <a:buNone/>
-            </a:pPr>
-            <a:r>
-              <a:rPr lang="en-US" sz="1400" b="1" dirty="0">
-                <a:solidFill>
-                  <a:srgbClr val="11121A"/>
-                </a:solidFill>
-                <a:latin typeface="Palatino Linotype" pitchFamily="34" charset="0"/>
-                <a:ea typeface="Palatino Linotype" pitchFamily="34" charset="-122"/>
-                <a:cs typeface="Palatino Linotype" pitchFamily="34" charset="-120"/>
-              </a:rPr>
-              <a:t>2</a:t>
-            </a:r>
-            <a:endParaRPr lang="en-US" sz="1400" dirty="0"/>
-          </a:p>
-        </p:txBody>
-      </p:sp>
-      <p:sp>
-        <p:nvSpPr>
-          <p:cNvPr id="12" name="Text 10"/>
-          <p:cNvSpPr/>
-          <p:nvPr/>
-        </p:nvSpPr>
-        <p:spPr>
-          <a:xfrm>
-            <a:off x="1600200" y="2642616"/>
-            <a:ext cx="9692640" cy="347472"/>
-          </a:xfrm>
-          <a:prstGeom prst="rect">
-            <a:avLst/>
-          </a:prstGeom>
-          <a:noFill/>
-          <a:ln/>
-        </p:spPr>
-        <p:txBody>
-          <a:bodyPr wrap="square" lIns="0" tIns="0" rIns="0" bIns="0" rtlCol="0" anchor="ctr"/>
-          <a:lstStyle/>
-          <a:p>
-            <a:pPr marL="0" indent="0">
-              <a:buNone/>
-            </a:pPr>
-            <a:r>
-              <a:rPr lang="en-US" sz="1450" b="1" dirty="0">
-                <a:solidFill>
-                  <a:srgbClr val="FFC24B"/>
-                </a:solidFill>
-                <a:latin typeface="Palatino Linotype" pitchFamily="34" charset="0"/>
-                <a:ea typeface="Palatino Linotype" pitchFamily="34" charset="-122"/>
-                <a:cs typeface="Palatino Linotype" pitchFamily="34" charset="-120"/>
-              </a:rPr>
-              <a:t>Căutați excepția aparentă.</a:t>
-            </a:r>
-            <a:endParaRPr lang="en-US" sz="1450" dirty="0"/>
-          </a:p>
-        </p:txBody>
-      </p:sp>
-      <p:sp>
-        <p:nvSpPr>
-          <p:cNvPr id="13" name="Text 11"/>
-          <p:cNvSpPr/>
-          <p:nvPr/>
-        </p:nvSpPr>
-        <p:spPr>
-          <a:xfrm>
-            <a:off x="1600200" y="2990088"/>
-            <a:ext cx="9692640" cy="365760"/>
-          </a:xfrm>
-          <a:prstGeom prst="rect">
-            <a:avLst/>
-          </a:prstGeom>
-          <a:noFill/>
-          <a:ln/>
-        </p:spPr>
-        <p:txBody>
-          <a:bodyPr wrap="square" lIns="0" tIns="0" rIns="0" bIns="0" rtlCol="0" anchor="ctr"/>
-          <a:lstStyle/>
-          <a:p>
-            <a:pPr marL="0" indent="0">
-              <a:buNone/>
-            </a:pPr>
-            <a:r>
-              <a:rPr lang="en-US" sz="1150" dirty="0">
-                <a:solidFill>
-                  <a:srgbClr val="FFFFFF"/>
-                </a:solidFill>
-                <a:latin typeface="Palatino Linotype" pitchFamily="34" charset="0"/>
-                <a:ea typeface="Palatino Linotype" pitchFamily="34" charset="-122"/>
-                <a:cs typeface="Palatino Linotype" pitchFamily="34" charset="-120"/>
-              </a:rPr>
-              <a:t>Nu „cine s-a îmbolnăvit?”, ci „cine părea expus și NU s-a îmbolnăvit?” — cu condiția să declarați ce anume mai diferea între grupuri.</a:t>
-            </a:r>
-            <a:endParaRPr lang="en-US" sz="1150" dirty="0"/>
-          </a:p>
-        </p:txBody>
-      </p:sp>
-      <p:sp>
-        <p:nvSpPr>
-          <p:cNvPr id="14" name="Shape 12"/>
-          <p:cNvSpPr/>
-          <p:nvPr/>
-        </p:nvSpPr>
-        <p:spPr>
-          <a:xfrm>
-            <a:off x="594360" y="3483864"/>
-            <a:ext cx="10972800" cy="786384"/>
-          </a:xfrm>
-          <a:prstGeom prst="roundRect">
-            <a:avLst>
-              <a:gd name="adj" fmla="val 10465"/>
-            </a:avLst>
-          </a:prstGeom>
-          <a:solidFill>
-            <a:srgbClr val="1D1F2B"/>
-          </a:solidFill>
-          <a:ln w="12700">
-            <a:solidFill>
-              <a:srgbClr val="1D1F2B"/>
-            </a:solidFill>
-            <a:prstDash val="solid"/>
-          </a:ln>
-        </p:spPr>
-        <p:txBody>
-          <a:bodyPr/>
-          <a:lstStyle/>
-          <a:p>
-            <a:endParaRPr lang="ro-RO"/>
-          </a:p>
-        </p:txBody>
-      </p:sp>
-      <p:sp>
-        <p:nvSpPr>
-          <p:cNvPr id="15" name="Shape 13"/>
-          <p:cNvSpPr/>
-          <p:nvPr/>
-        </p:nvSpPr>
-        <p:spPr>
-          <a:xfrm>
-            <a:off x="914400" y="3666744"/>
-            <a:ext cx="438912" cy="438912"/>
-          </a:xfrm>
-          <a:prstGeom prst="ellipse">
-            <a:avLst/>
-          </a:prstGeom>
-          <a:solidFill>
-            <a:srgbClr val="27D3BE"/>
-          </a:solidFill>
-          <a:ln/>
-        </p:spPr>
-        <p:txBody>
-          <a:bodyPr/>
-          <a:lstStyle/>
-          <a:p>
-            <a:endParaRPr lang="ro-RO"/>
-          </a:p>
-        </p:txBody>
-      </p:sp>
-      <p:sp>
-        <p:nvSpPr>
-          <p:cNvPr id="16" name="Text 14"/>
-          <p:cNvSpPr/>
-          <p:nvPr/>
-        </p:nvSpPr>
-        <p:spPr>
-          <a:xfrm>
-            <a:off x="914400" y="3666744"/>
-            <a:ext cx="438912" cy="438912"/>
-          </a:xfrm>
-          <a:prstGeom prst="rect">
-            <a:avLst/>
-          </a:prstGeom>
-          <a:noFill/>
-          <a:ln/>
-        </p:spPr>
-        <p:txBody>
-          <a:bodyPr wrap="square" lIns="0" tIns="0" rIns="0" bIns="0" rtlCol="0" anchor="ctr"/>
-          <a:lstStyle/>
-          <a:p>
-            <a:pPr marL="0" indent="0" algn="ctr">
-              <a:buNone/>
-            </a:pPr>
-            <a:r>
-              <a:rPr lang="en-US" sz="1400" b="1" dirty="0">
-                <a:solidFill>
-                  <a:srgbClr val="11121A"/>
-                </a:solidFill>
-                <a:latin typeface="Palatino Linotype" pitchFamily="34" charset="0"/>
-                <a:ea typeface="Palatino Linotype" pitchFamily="34" charset="-122"/>
-                <a:cs typeface="Palatino Linotype" pitchFamily="34" charset="-120"/>
-              </a:rPr>
-              <a:t>3</a:t>
-            </a:r>
-            <a:endParaRPr lang="en-US" sz="1400" dirty="0"/>
-          </a:p>
-        </p:txBody>
-      </p:sp>
-      <p:sp>
-        <p:nvSpPr>
-          <p:cNvPr id="17" name="Text 15"/>
-          <p:cNvSpPr/>
-          <p:nvPr/>
-        </p:nvSpPr>
-        <p:spPr>
-          <a:xfrm>
-            <a:off x="1600200" y="3538728"/>
-            <a:ext cx="9692640" cy="347472"/>
-          </a:xfrm>
-          <a:prstGeom prst="rect">
-            <a:avLst/>
-          </a:prstGeom>
-          <a:noFill/>
-          <a:ln/>
-        </p:spPr>
-        <p:txBody>
-          <a:bodyPr wrap="square" lIns="0" tIns="0" rIns="0" bIns="0" rtlCol="0" anchor="ctr"/>
-          <a:lstStyle/>
-          <a:p>
-            <a:pPr marL="0" indent="0">
-              <a:buNone/>
-            </a:pPr>
-            <a:r>
-              <a:rPr lang="en-US" sz="1450" b="1" dirty="0">
-                <a:solidFill>
-                  <a:srgbClr val="27D3BE"/>
-                </a:solidFill>
-                <a:latin typeface="Palatino Linotype" pitchFamily="34" charset="0"/>
-                <a:ea typeface="Palatino Linotype" pitchFamily="34" charset="-122"/>
-                <a:cs typeface="Palatino Linotype" pitchFamily="34" charset="-120"/>
-              </a:rPr>
-              <a:t>Acționați sub incertitudine, fără să confundați acțiunea cu dovada.</a:t>
-            </a:r>
-            <a:endParaRPr lang="en-US" sz="1450" dirty="0"/>
-          </a:p>
-        </p:txBody>
-      </p:sp>
-      <p:sp>
-        <p:nvSpPr>
-          <p:cNvPr id="18" name="Text 16"/>
-          <p:cNvSpPr/>
-          <p:nvPr/>
-        </p:nvSpPr>
-        <p:spPr>
-          <a:xfrm>
-            <a:off x="1600200" y="3886200"/>
-            <a:ext cx="9692640" cy="365760"/>
-          </a:xfrm>
-          <a:prstGeom prst="rect">
-            <a:avLst/>
-          </a:prstGeom>
-          <a:noFill/>
-          <a:ln/>
-        </p:spPr>
-        <p:txBody>
-          <a:bodyPr wrap="square" lIns="0" tIns="0" rIns="0" bIns="0" rtlCol="0" anchor="ctr"/>
-          <a:lstStyle/>
-          <a:p>
-            <a:pPr marL="0" indent="0">
-              <a:buNone/>
-            </a:pPr>
-            <a:r>
-              <a:rPr lang="en-US" sz="1150" dirty="0">
-                <a:solidFill>
-                  <a:srgbClr val="FFFFFF"/>
-                </a:solidFill>
-                <a:latin typeface="Palatino Linotype" pitchFamily="34" charset="0"/>
-                <a:ea typeface="Palatino Linotype" pitchFamily="34" charset="-122"/>
-                <a:cs typeface="Palatino Linotype" pitchFamily="34" charset="-120"/>
-              </a:rPr>
-              <a:t>Mânerul a fost probabil scos corect, deși atacurile scădeau deja. În Guineea au trecut aproape trei luni între debutul primului caz și alertarea OMS.</a:t>
-            </a:r>
-            <a:endParaRPr lang="en-US" sz="1150" dirty="0"/>
-          </a:p>
-        </p:txBody>
-      </p:sp>
-      <p:sp>
-        <p:nvSpPr>
-          <p:cNvPr id="19" name="Shape 17"/>
-          <p:cNvSpPr/>
-          <p:nvPr/>
-        </p:nvSpPr>
-        <p:spPr>
-          <a:xfrm>
-            <a:off x="594360" y="4379976"/>
-            <a:ext cx="10972800" cy="786384"/>
-          </a:xfrm>
-          <a:prstGeom prst="roundRect">
-            <a:avLst>
-              <a:gd name="adj" fmla="val 10465"/>
-            </a:avLst>
-          </a:prstGeom>
-          <a:solidFill>
-            <a:srgbClr val="2A2438"/>
-          </a:solidFill>
-          <a:ln w="12700">
-            <a:solidFill>
-              <a:srgbClr val="2A2438"/>
-            </a:solidFill>
-            <a:prstDash val="solid"/>
-          </a:ln>
-        </p:spPr>
-        <p:txBody>
-          <a:bodyPr/>
-          <a:lstStyle/>
-          <a:p>
-            <a:endParaRPr lang="ro-RO"/>
-          </a:p>
-        </p:txBody>
-      </p:sp>
-      <p:sp>
-        <p:nvSpPr>
-          <p:cNvPr id="20" name="Shape 18"/>
-          <p:cNvSpPr/>
-          <p:nvPr/>
-        </p:nvSpPr>
-        <p:spPr>
-          <a:xfrm>
-            <a:off x="914400" y="4562856"/>
-            <a:ext cx="438912" cy="438912"/>
-          </a:xfrm>
-          <a:prstGeom prst="ellipse">
-            <a:avLst/>
-          </a:prstGeom>
-          <a:solidFill>
-            <a:srgbClr val="9B7EF7"/>
-          </a:solidFill>
-          <a:ln/>
-        </p:spPr>
-        <p:txBody>
-          <a:bodyPr/>
-          <a:lstStyle/>
-          <a:p>
-            <a:endParaRPr lang="ro-RO"/>
-          </a:p>
-        </p:txBody>
-      </p:sp>
-      <p:sp>
-        <p:nvSpPr>
-          <p:cNvPr id="21" name="Text 19"/>
-          <p:cNvSpPr/>
-          <p:nvPr/>
-        </p:nvSpPr>
-        <p:spPr>
-          <a:xfrm>
-            <a:off x="914400" y="4562856"/>
-            <a:ext cx="438912" cy="438912"/>
-          </a:xfrm>
-          <a:prstGeom prst="rect">
-            <a:avLst/>
-          </a:prstGeom>
-          <a:noFill/>
-          <a:ln/>
-        </p:spPr>
-        <p:txBody>
-          <a:bodyPr wrap="square" lIns="0" tIns="0" rIns="0" bIns="0" rtlCol="0" anchor="ctr"/>
-          <a:lstStyle/>
-          <a:p>
-            <a:pPr marL="0" indent="0" algn="ctr">
-              <a:buNone/>
-            </a:pPr>
-            <a:r>
-              <a:rPr lang="en-US" sz="1400" b="1" dirty="0">
-                <a:solidFill>
-                  <a:srgbClr val="11121A"/>
-                </a:solidFill>
-                <a:latin typeface="Palatino Linotype" pitchFamily="34" charset="0"/>
-                <a:ea typeface="Palatino Linotype" pitchFamily="34" charset="-122"/>
-                <a:cs typeface="Palatino Linotype" pitchFamily="34" charset="-120"/>
-              </a:rPr>
-              <a:t>4</a:t>
-            </a:r>
-            <a:endParaRPr lang="en-US" sz="1400" dirty="0"/>
-          </a:p>
-        </p:txBody>
-      </p:sp>
-      <p:sp>
-        <p:nvSpPr>
-          <p:cNvPr id="22" name="Text 20"/>
-          <p:cNvSpPr/>
-          <p:nvPr/>
-        </p:nvSpPr>
-        <p:spPr>
-          <a:xfrm>
-            <a:off x="1600200" y="4434840"/>
-            <a:ext cx="9692640" cy="347472"/>
-          </a:xfrm>
-          <a:prstGeom prst="rect">
-            <a:avLst/>
-          </a:prstGeom>
-          <a:noFill/>
-          <a:ln/>
-        </p:spPr>
-        <p:txBody>
-          <a:bodyPr wrap="square" lIns="0" tIns="0" rIns="0" bIns="0" rtlCol="0" anchor="ctr"/>
-          <a:lstStyle/>
-          <a:p>
-            <a:pPr marL="0" indent="0">
-              <a:buNone/>
-            </a:pPr>
-            <a:r>
-              <a:rPr lang="en-US" sz="1450" b="1" dirty="0">
-                <a:solidFill>
-                  <a:srgbClr val="9B7EF7"/>
-                </a:solidFill>
-                <a:latin typeface="Palatino Linotype" pitchFamily="34" charset="0"/>
-                <a:ea typeface="Palatino Linotype" pitchFamily="34" charset="-122"/>
-                <a:cs typeface="Palatino Linotype" pitchFamily="34" charset="-120"/>
-              </a:rPr>
-              <a:t>Spuneți „nu a fost identificat”, nu „nu există”.</a:t>
-            </a:r>
-            <a:endParaRPr lang="en-US" sz="1450" dirty="0"/>
-          </a:p>
-        </p:txBody>
-      </p:sp>
-      <p:sp>
-        <p:nvSpPr>
-          <p:cNvPr id="23" name="Text 21"/>
-          <p:cNvSpPr/>
-          <p:nvPr/>
-        </p:nvSpPr>
-        <p:spPr>
-          <a:xfrm>
-            <a:off x="1600200" y="4782312"/>
-            <a:ext cx="9692640" cy="365760"/>
-          </a:xfrm>
-          <a:prstGeom prst="rect">
-            <a:avLst/>
-          </a:prstGeom>
-          <a:noFill/>
-          <a:ln/>
-        </p:spPr>
-        <p:txBody>
-          <a:bodyPr wrap="square" lIns="0" tIns="0" rIns="0" bIns="0" rtlCol="0" anchor="ctr"/>
-          <a:lstStyle/>
-          <a:p>
-            <a:pPr marL="0" indent="0">
-              <a:buNone/>
-            </a:pPr>
-            <a:r>
-              <a:rPr lang="en-US" sz="1150" dirty="0">
-                <a:solidFill>
-                  <a:srgbClr val="FFFFFF"/>
-                </a:solidFill>
-                <a:latin typeface="Palatino Linotype" pitchFamily="34" charset="0"/>
-                <a:ea typeface="Palatino Linotype" pitchFamily="34" charset="-122"/>
-                <a:cs typeface="Palatino Linotype" pitchFamily="34" charset="-120"/>
-              </a:rPr>
-              <a:t>Ca la Hassall: un rezultat de laborator negativ a fost citit ca dovadă a absenței.</a:t>
-            </a:r>
-            <a:endParaRPr lang="en-US" sz="1150" dirty="0"/>
-          </a:p>
-        </p:txBody>
-      </p:sp>
-      <p:sp>
-        <p:nvSpPr>
-          <p:cNvPr id="24" name="Shape 22"/>
-          <p:cNvSpPr/>
-          <p:nvPr/>
-        </p:nvSpPr>
-        <p:spPr>
-          <a:xfrm>
-            <a:off x="594360" y="5276088"/>
-            <a:ext cx="10972800" cy="786384"/>
-          </a:xfrm>
-          <a:prstGeom prst="roundRect">
-            <a:avLst>
-              <a:gd name="adj" fmla="val 10465"/>
-            </a:avLst>
-          </a:prstGeom>
-          <a:solidFill>
-            <a:srgbClr val="2A2438"/>
-          </a:solidFill>
-          <a:ln w="12700">
-            <a:solidFill>
-              <a:srgbClr val="2A2438"/>
-            </a:solidFill>
-            <a:prstDash val="solid"/>
-          </a:ln>
-        </p:spPr>
-        <p:txBody>
-          <a:bodyPr/>
-          <a:lstStyle/>
-          <a:p>
-            <a:endParaRPr lang="ro-RO"/>
-          </a:p>
-        </p:txBody>
-      </p:sp>
-      <p:sp>
-        <p:nvSpPr>
-          <p:cNvPr id="25" name="Shape 23"/>
-          <p:cNvSpPr/>
-          <p:nvPr/>
-        </p:nvSpPr>
-        <p:spPr>
-          <a:xfrm>
-            <a:off x="914400" y="5458968"/>
-            <a:ext cx="438912" cy="438912"/>
-          </a:xfrm>
-          <a:prstGeom prst="ellipse">
-            <a:avLst/>
-          </a:prstGeom>
-          <a:solidFill>
-            <a:srgbClr val="FF8A3D"/>
-          </a:solidFill>
-          <a:ln/>
-        </p:spPr>
-        <p:txBody>
-          <a:bodyPr/>
-          <a:lstStyle/>
-          <a:p>
-            <a:endParaRPr lang="ro-RO"/>
-          </a:p>
-        </p:txBody>
-      </p:sp>
-      <p:sp>
-        <p:nvSpPr>
-          <p:cNvPr id="26" name="Text 24"/>
-          <p:cNvSpPr/>
-          <p:nvPr/>
-        </p:nvSpPr>
-        <p:spPr>
-          <a:xfrm>
-            <a:off x="914400" y="5458968"/>
-            <a:ext cx="438912" cy="438912"/>
-          </a:xfrm>
-          <a:prstGeom prst="rect">
-            <a:avLst/>
-          </a:prstGeom>
-          <a:noFill/>
-          <a:ln/>
-        </p:spPr>
-        <p:txBody>
-          <a:bodyPr wrap="square" lIns="0" tIns="0" rIns="0" bIns="0" rtlCol="0" anchor="ctr"/>
-          <a:lstStyle/>
-          <a:p>
-            <a:pPr marL="0" indent="0" algn="ctr">
-              <a:buNone/>
-            </a:pPr>
-            <a:r>
-              <a:rPr lang="en-US" sz="1400" b="1" dirty="0">
-                <a:solidFill>
-                  <a:srgbClr val="11121A"/>
-                </a:solidFill>
-                <a:latin typeface="Palatino Linotype" pitchFamily="34" charset="0"/>
-                <a:ea typeface="Palatino Linotype" pitchFamily="34" charset="-122"/>
-                <a:cs typeface="Palatino Linotype" pitchFamily="34" charset="-120"/>
-              </a:rPr>
-              <a:t>5</a:t>
-            </a:r>
-            <a:endParaRPr lang="en-US" sz="1400" dirty="0"/>
-          </a:p>
-        </p:txBody>
-      </p:sp>
-      <p:sp>
-        <p:nvSpPr>
-          <p:cNvPr id="27" name="Text 25"/>
-          <p:cNvSpPr/>
-          <p:nvPr/>
-        </p:nvSpPr>
-        <p:spPr>
-          <a:xfrm>
-            <a:off x="1600200" y="5330952"/>
-            <a:ext cx="9692640" cy="347472"/>
-          </a:xfrm>
-          <a:prstGeom prst="rect">
-            <a:avLst/>
-          </a:prstGeom>
-          <a:noFill/>
-          <a:ln/>
-        </p:spPr>
-        <p:txBody>
-          <a:bodyPr wrap="square" lIns="0" tIns="0" rIns="0" bIns="0" rtlCol="0" anchor="ctr"/>
-          <a:lstStyle/>
-          <a:p>
-            <a:pPr marL="0" indent="0">
-              <a:buNone/>
-            </a:pPr>
-            <a:r>
-              <a:rPr lang="en-US" sz="1450" b="1" dirty="0">
-                <a:solidFill>
-                  <a:srgbClr val="FF8A3D"/>
-                </a:solidFill>
-                <a:latin typeface="Palatino Linotype" pitchFamily="34" charset="0"/>
-                <a:ea typeface="Palatino Linotype" pitchFamily="34" charset="-122"/>
-                <a:cs typeface="Palatino Linotype" pitchFamily="34" charset="-120"/>
-              </a:rPr>
-              <a:t>Nu puteți verifica tot. Verificați ce schimbă o decizie.</a:t>
-            </a:r>
-            <a:endParaRPr lang="en-US" sz="1450" dirty="0"/>
-          </a:p>
-        </p:txBody>
-      </p:sp>
-      <p:sp>
-        <p:nvSpPr>
-          <p:cNvPr id="28" name="Text 26"/>
-          <p:cNvSpPr/>
-          <p:nvPr/>
-        </p:nvSpPr>
-        <p:spPr>
-          <a:xfrm>
-            <a:off x="1600200" y="5678424"/>
-            <a:ext cx="9692640" cy="365760"/>
-          </a:xfrm>
-          <a:prstGeom prst="rect">
-            <a:avLst/>
-          </a:prstGeom>
-          <a:noFill/>
-          <a:ln/>
-        </p:spPr>
-        <p:txBody>
-          <a:bodyPr wrap="square" lIns="0" tIns="0" rIns="0" bIns="0" rtlCol="0" anchor="ctr"/>
-          <a:lstStyle/>
-          <a:p>
-            <a:pPr marL="0" indent="0">
-              <a:buNone/>
-            </a:pPr>
-            <a:r>
-              <a:rPr lang="en-US" sz="1150" dirty="0">
-                <a:solidFill>
-                  <a:srgbClr val="FFFFFF"/>
-                </a:solidFill>
-                <a:latin typeface="Palatino Linotype" pitchFamily="34" charset="0"/>
-                <a:ea typeface="Palatino Linotype" pitchFamily="34" charset="-122"/>
-                <a:cs typeface="Palatino Linotype" pitchFamily="34" charset="-120"/>
-              </a:rPr>
-              <a:t>Nu veți verifica paginația unui volum vechi. Veți putea întreba întotdeauna care e numitorul unei rate.</a:t>
-            </a:r>
-            <a:endParaRPr lang="en-US" sz="1150" dirty="0"/>
-          </a:p>
-        </p:txBody>
-      </p:sp>
-      <p:sp>
-        <p:nvSpPr>
-          <p:cNvPr id="29" name="Text 27"/>
-          <p:cNvSpPr/>
-          <p:nvPr/>
-        </p:nvSpPr>
-        <p:spPr>
-          <a:xfrm>
-            <a:off x="594360" y="6236208"/>
-            <a:ext cx="10972800" cy="320040"/>
-          </a:xfrm>
-          <a:prstGeom prst="rect">
-            <a:avLst/>
-          </a:prstGeom>
-          <a:noFill/>
-          <a:ln/>
-        </p:spPr>
-        <p:txBody>
-          <a:bodyPr wrap="square" lIns="0" tIns="0" rIns="0" bIns="0" rtlCol="0" anchor="ctr"/>
-          <a:lstStyle/>
-          <a:p>
-            <a:pPr marL="0" indent="0">
-              <a:buNone/>
-            </a:pPr>
-            <a:r>
-              <a:rPr lang="en-US" sz="1200" i="1" dirty="0">
-                <a:solidFill>
-                  <a:srgbClr val="959BB0"/>
-                </a:solidFill>
-                <a:latin typeface="Palatino Linotype" pitchFamily="34" charset="0"/>
-                <a:ea typeface="Palatino Linotype" pitchFamily="34" charset="-122"/>
-                <a:cs typeface="Palatino Linotype" pitchFamily="34" charset="-120"/>
-              </a:rPr>
-              <a:t>Regula 5 nu se deduce din datele de mai sus. Se deduce din experiența pregătirii acestei sesiuni.</a:t>
-            </a:r>
-            <a:endParaRPr lang="en-US" sz="1200" dirty="0"/>
-          </a:p>
-        </p:txBody>
-      </p:sp>
-    </p:spTree>
-  </p:cSld>
-  <p:clrMapOvr>
-    <a:masterClrMapping/>
-  </p:clrMapOvr>
-</p:sld>
-</file>
-
-<file path=ppt/slides/slide51.xml><?xml version="1.0" encoding="utf-8"?>
-<p:sld xmlns:a="http://schemas.openxmlformats.org/drawingml/2006/main" xmlns:r="http://schemas.openxmlformats.org/officeDocument/2006/relationships" xmlns:p="http://schemas.openxmlformats.org/presentationml/2006/main">
-  <p:cSld name="Slide 50">
-    <p:bg>
-      <p:bgPr>
-        <a:solidFill>
-          <a:srgbClr val="F6F5F2"/>
-        </a:solidFill>
-        <a:effectLst/>
-      </p:bgPr>
-    </p:bg>
-    <p:spTree>
-      <p:nvGrpSpPr>
-        <p:cNvPr id="1" name=""/>
-        <p:cNvGrpSpPr/>
-        <p:nvPr/>
-      </p:nvGrpSpPr>
-      <p:grpSpPr>
-        <a:xfrm>
-          <a:off x="0" y="0"/>
-          <a:ext cx="0" cy="0"/>
-          <a:chOff x="0" y="0"/>
-          <a:chExt cx="0" cy="0"/>
-        </a:xfrm>
-      </p:grpSpPr>
-      <p:sp>
-        <p:nvSpPr>
-          <p:cNvPr id="2" name="Text 0"/>
-          <p:cNvSpPr/>
-          <p:nvPr/>
-        </p:nvSpPr>
-        <p:spPr>
-          <a:xfrm>
-            <a:off x="594360" y="365760"/>
-            <a:ext cx="8229600" cy="310896"/>
-          </a:xfrm>
-          <a:prstGeom prst="rect">
-            <a:avLst/>
-          </a:prstGeom>
-          <a:noFill/>
-          <a:ln/>
-        </p:spPr>
-        <p:txBody>
-          <a:bodyPr wrap="square" lIns="0" tIns="0" rIns="0" bIns="0" rtlCol="0" anchor="ctr"/>
-          <a:lstStyle/>
-          <a:p>
-            <a:pPr marL="0" indent="0">
-              <a:buNone/>
-            </a:pPr>
-            <a:r>
-              <a:rPr lang="en-US" sz="1150" b="1" kern="0" spc="300" dirty="0">
-                <a:solidFill>
-                  <a:srgbClr val="FF4757"/>
-                </a:solidFill>
-                <a:latin typeface="Palatino Linotype" pitchFamily="34" charset="0"/>
-                <a:ea typeface="Palatino Linotype" pitchFamily="34" charset="-122"/>
-                <a:cs typeface="Palatino Linotype" pitchFamily="34" charset="-120"/>
-              </a:rPr>
-              <a:t>VERIFICABIL</a:t>
-            </a:r>
-            <a:endParaRPr lang="en-US" sz="1150" dirty="0"/>
-          </a:p>
-        </p:txBody>
-      </p:sp>
-      <p:sp>
-        <p:nvSpPr>
-          <p:cNvPr id="3" name="Text 1"/>
-          <p:cNvSpPr/>
-          <p:nvPr/>
-        </p:nvSpPr>
-        <p:spPr>
-          <a:xfrm>
-            <a:off x="594360" y="694944"/>
-            <a:ext cx="10972800" cy="960120"/>
-          </a:xfrm>
-          <a:prstGeom prst="rect">
-            <a:avLst/>
-          </a:prstGeom>
-          <a:noFill/>
-          <a:ln/>
-        </p:spPr>
-        <p:txBody>
-          <a:bodyPr wrap="square" lIns="0" tIns="0" rIns="0" bIns="0" rtlCol="0" anchor="t"/>
-          <a:lstStyle/>
-          <a:p>
-            <a:pPr marL="0" indent="0">
-              <a:buNone/>
-            </a:pPr>
-            <a:r>
-              <a:rPr lang="en-US" sz="3100" b="1" dirty="0">
-                <a:solidFill>
-                  <a:srgbClr val="11121A"/>
-                </a:solidFill>
-                <a:latin typeface="Palatino Linotype" pitchFamily="34" charset="0"/>
-                <a:ea typeface="Palatino Linotype" pitchFamily="34" charset="-122"/>
-                <a:cs typeface="Palatino Linotype" pitchFamily="34" charset="-120"/>
-              </a:rPr>
-              <a:t>Sursele acestei sesiuni</a:t>
-            </a:r>
-            <a:endParaRPr lang="en-US" sz="3100" dirty="0"/>
-          </a:p>
-        </p:txBody>
-      </p:sp>
-      <p:sp>
-        <p:nvSpPr>
-          <p:cNvPr id="4" name="Text 2"/>
-          <p:cNvSpPr/>
-          <p:nvPr/>
-        </p:nvSpPr>
-        <p:spPr>
-          <a:xfrm>
-            <a:off x="594360" y="1645920"/>
-            <a:ext cx="10972800" cy="310896"/>
-          </a:xfrm>
-          <a:prstGeom prst="rect">
-            <a:avLst/>
-          </a:prstGeom>
-          <a:noFill/>
-          <a:ln/>
-        </p:spPr>
-        <p:txBody>
-          <a:bodyPr wrap="square" lIns="0" tIns="0" rIns="0" bIns="0" rtlCol="0" anchor="ctr"/>
-          <a:lstStyle/>
-          <a:p>
-            <a:pPr marL="0" indent="0">
-              <a:buNone/>
-            </a:pPr>
-            <a:r>
-              <a:rPr lang="en-US" sz="1200" i="1" dirty="0">
-                <a:solidFill>
-                  <a:srgbClr val="585A64"/>
-                </a:solidFill>
-                <a:latin typeface="Palatino Linotype" pitchFamily="34" charset="0"/>
-                <a:ea typeface="Palatino Linotype" pitchFamily="34" charset="-122"/>
-                <a:cs typeface="Palatino Linotype" pitchFamily="34" charset="-120"/>
-              </a:rPr>
-              <a:t>Fiecare cifră are o afirmație în registrul public al surselor, cu pagina și data verificării. Toate corecturile de conținut aduse versiunilor întâi–a treia sunt în anexa notelor de curs.</a:t>
-            </a:r>
-            <a:endParaRPr lang="en-US" sz="1200" dirty="0"/>
-          </a:p>
-        </p:txBody>
-      </p:sp>
-      <p:sp>
-        <p:nvSpPr>
-          <p:cNvPr id="5" name="Shape 3"/>
-          <p:cNvSpPr/>
-          <p:nvPr/>
-        </p:nvSpPr>
-        <p:spPr>
-          <a:xfrm>
-            <a:off x="594360" y="2057400"/>
-            <a:ext cx="5349240" cy="3931920"/>
-          </a:xfrm>
-          <a:prstGeom prst="roundRect">
-            <a:avLst>
-              <a:gd name="adj" fmla="val 2093"/>
-            </a:avLst>
-          </a:prstGeom>
-          <a:solidFill>
-            <a:srgbClr val="ECEAE4"/>
-          </a:solidFill>
-          <a:ln w="12700">
-            <a:solidFill>
-              <a:srgbClr val="ECEAE4"/>
-            </a:solidFill>
-            <a:prstDash val="solid"/>
-          </a:ln>
-        </p:spPr>
-        <p:txBody>
-          <a:bodyPr/>
-          <a:lstStyle/>
-          <a:p>
-            <a:endParaRPr lang="ro-RO"/>
-          </a:p>
-        </p:txBody>
-      </p:sp>
-      <p:sp>
-        <p:nvSpPr>
-          <p:cNvPr id="6" name="Text 4"/>
-          <p:cNvSpPr/>
-          <p:nvPr/>
-        </p:nvSpPr>
-        <p:spPr>
-          <a:xfrm>
-            <a:off x="914400" y="2194560"/>
-            <a:ext cx="4709160" cy="292608"/>
-          </a:xfrm>
-          <a:prstGeom prst="rect">
-            <a:avLst/>
-          </a:prstGeom>
-          <a:noFill/>
-          <a:ln/>
-        </p:spPr>
-        <p:txBody>
-          <a:bodyPr wrap="square" lIns="0" tIns="0" rIns="0" bIns="0" rtlCol="0" anchor="ctr"/>
-          <a:lstStyle/>
-          <a:p>
-            <a:pPr marL="0" indent="0">
-              <a:buNone/>
-            </a:pPr>
-            <a:r>
-              <a:rPr lang="en-US" sz="1350" b="1" dirty="0">
-                <a:solidFill>
-                  <a:srgbClr val="4A2D8C"/>
-                </a:solidFill>
-                <a:latin typeface="Palatino Linotype" pitchFamily="34" charset="0"/>
-                <a:ea typeface="Palatino Linotype" pitchFamily="34" charset="-122"/>
-                <a:cs typeface="Palatino Linotype" pitchFamily="34" charset="-120"/>
-              </a:rPr>
-              <a:t>1854 — surse primare, integral pe archive.org</a:t>
-            </a:r>
-            <a:endParaRPr lang="en-US" sz="1350" dirty="0"/>
-          </a:p>
-        </p:txBody>
-      </p:sp>
-      <p:sp>
-        <p:nvSpPr>
-          <p:cNvPr id="7" name="Text 5"/>
-          <p:cNvSpPr/>
-          <p:nvPr/>
-        </p:nvSpPr>
-        <p:spPr>
-          <a:xfrm>
-            <a:off x="1051560" y="2560320"/>
-            <a:ext cx="4663440" cy="3291840"/>
-          </a:xfrm>
-          <a:prstGeom prst="rect">
-            <a:avLst/>
-          </a:prstGeom>
-          <a:noFill/>
-          <a:ln/>
-        </p:spPr>
-        <p:txBody>
-          <a:bodyPr wrap="square" lIns="0" tIns="0" rIns="0" bIns="0" rtlCol="0" anchor="t"/>
-          <a:lstStyle/>
-          <a:p>
-            <a:pPr marL="0" indent="0">
-              <a:spcAft>
-                <a:spcPts val="400"/>
-              </a:spcAft>
-              <a:buNone/>
-            </a:pPr>
-            <a:r>
-              <a:rPr lang="en-US" sz="900" dirty="0">
-                <a:solidFill>
-                  <a:srgbClr val="11121A"/>
-                </a:solidFill>
-                <a:latin typeface="Palatino Linotype" pitchFamily="34" charset="0"/>
-                <a:ea typeface="Palatino Linotype" pitchFamily="34" charset="-122"/>
-                <a:cs typeface="Palatino Linotype" pitchFamily="34" charset="-120"/>
-              </a:rPr>
-              <a:t>[1] Snow J. On the Mode of Communication of Cholera, ed. 2. Londra: Churchill, 1855.</a:t>
-            </a:r>
-            <a:endParaRPr lang="en-US" sz="900" dirty="0"/>
-          </a:p>
-          <a:p>
-            <a:pPr marL="0" indent="0">
-              <a:spcAft>
-                <a:spcPts val="400"/>
-              </a:spcAft>
-              <a:buNone/>
-            </a:pPr>
-            <a:r>
-              <a:rPr lang="en-US" sz="900" dirty="0">
-                <a:solidFill>
-                  <a:srgbClr val="11121A"/>
-                </a:solidFill>
-                <a:latin typeface="Palatino Linotype" pitchFamily="34" charset="0"/>
-                <a:ea typeface="Palatino Linotype" pitchFamily="34" charset="-122"/>
-                <a:cs typeface="Palatino Linotype" pitchFamily="34" charset="-120"/>
-              </a:rPr>
-              <a:t>[2] Cholera Inquiry Committee. Report on the Cholera Outbreak in the Parish of St. James, Westminster. Londra, 1855.</a:t>
-            </a:r>
-            <a:endParaRPr lang="en-US" sz="900" dirty="0"/>
-          </a:p>
-          <a:p>
-            <a:pPr marL="0" indent="0">
-              <a:spcAft>
-                <a:spcPts val="400"/>
-              </a:spcAft>
-              <a:buNone/>
-            </a:pPr>
-            <a:r>
-              <a:rPr lang="en-US" sz="900" dirty="0">
-                <a:solidFill>
-                  <a:srgbClr val="11121A"/>
-                </a:solidFill>
-                <a:latin typeface="Palatino Linotype" pitchFamily="34" charset="0"/>
-                <a:ea typeface="Palatino Linotype" pitchFamily="34" charset="-122"/>
-                <a:cs typeface="Palatino Linotype" pitchFamily="34" charset="-120"/>
-              </a:rPr>
-              <a:t>[3] General Board of Health. Report of the Committee for Scientific Inquiries… Londra, 1855.</a:t>
-            </a:r>
-            <a:endParaRPr lang="en-US" sz="900" dirty="0"/>
-          </a:p>
-          <a:p>
-            <a:pPr marL="0" indent="0">
-              <a:spcAft>
-                <a:spcPts val="400"/>
-              </a:spcAft>
-              <a:buNone/>
-            </a:pPr>
-            <a:r>
-              <a:rPr lang="en-US" sz="900" dirty="0">
-                <a:solidFill>
-                  <a:srgbClr val="11121A"/>
-                </a:solidFill>
-                <a:latin typeface="Palatino Linotype" pitchFamily="34" charset="0"/>
-                <a:ea typeface="Palatino Linotype" pitchFamily="34" charset="-122"/>
-                <a:cs typeface="Palatino Linotype" pitchFamily="34" charset="-120"/>
-              </a:rPr>
-              <a:t>[4] McLeod KS. Soc Sci Med. 2000;50(7–8):923–935. DOI: 10.1016/s0277-9536(99)00345-7</a:t>
-            </a:r>
-            <a:endParaRPr lang="en-US" sz="900" dirty="0"/>
-          </a:p>
-          <a:p>
-            <a:pPr marL="0" indent="0">
-              <a:spcAft>
-                <a:spcPts val="400"/>
-              </a:spcAft>
-              <a:buNone/>
-            </a:pPr>
-            <a:r>
-              <a:rPr lang="en-US" sz="900" dirty="0">
-                <a:solidFill>
-                  <a:srgbClr val="11121A"/>
-                </a:solidFill>
-                <a:latin typeface="Palatino Linotype" pitchFamily="34" charset="0"/>
-                <a:ea typeface="Palatino Linotype" pitchFamily="34" charset="-122"/>
-                <a:cs typeface="Palatino Linotype" pitchFamily="34" charset="-120"/>
-              </a:rPr>
-              <a:t>[5] Brody H et al. Lancet. 2000;356(9223):64–68. DOI: 10.1016/S0140-6736(00)02442-9</a:t>
-            </a:r>
-            <a:endParaRPr lang="en-US" sz="900" dirty="0"/>
-          </a:p>
-          <a:p>
-            <a:pPr marL="0" indent="0">
-              <a:spcAft>
-                <a:spcPts val="400"/>
-              </a:spcAft>
-              <a:buNone/>
-            </a:pPr>
-            <a:r>
-              <a:rPr lang="en-US" sz="900" dirty="0">
-                <a:solidFill>
-                  <a:srgbClr val="11121A"/>
-                </a:solidFill>
-                <a:latin typeface="Palatino Linotype" pitchFamily="34" charset="0"/>
-                <a:ea typeface="Palatino Linotype" pitchFamily="34" charset="-122"/>
-                <a:cs typeface="Palatino Linotype" pitchFamily="34" charset="-120"/>
-              </a:rPr>
-              <a:t>[6] Paneth N et al. Am J Public Health. 1998;88(10):1545–1553. DOI: 10.2105/ajph.88.10.1545</a:t>
-            </a:r>
-            <a:endParaRPr lang="en-US" sz="900" dirty="0"/>
-          </a:p>
-          <a:p>
-            <a:pPr marL="0" indent="0">
-              <a:spcAft>
-                <a:spcPts val="400"/>
-              </a:spcAft>
-              <a:buNone/>
-            </a:pPr>
-            <a:r>
-              <a:rPr lang="en-US" sz="900" dirty="0">
-                <a:solidFill>
-                  <a:srgbClr val="11121A"/>
-                </a:solidFill>
-                <a:latin typeface="Palatino Linotype" pitchFamily="34" charset="0"/>
-                <a:ea typeface="Palatino Linotype" pitchFamily="34" charset="-122"/>
-                <a:cs typeface="Palatino Linotype" pitchFamily="34" charset="-120"/>
-              </a:rPr>
-              <a:t>[7] Vandenbroucke JP et al. Am J Epidemiol. 1991;133(10):967–973. DOI: 10.1093/oxfordjournals.aje.a115816</a:t>
-            </a:r>
-            <a:endParaRPr lang="en-US" sz="900" dirty="0"/>
-          </a:p>
-          <a:p>
-            <a:pPr marL="0" indent="0">
-              <a:spcAft>
-                <a:spcPts val="400"/>
-              </a:spcAft>
-              <a:buNone/>
-            </a:pPr>
-            <a:r>
-              <a:rPr lang="en-US" sz="900" dirty="0">
-                <a:solidFill>
-                  <a:srgbClr val="11121A"/>
-                </a:solidFill>
-                <a:latin typeface="Palatino Linotype" pitchFamily="34" charset="0"/>
-                <a:ea typeface="Palatino Linotype" pitchFamily="34" charset="-122"/>
-                <a:cs typeface="Palatino Linotype" pitchFamily="34" charset="-120"/>
-              </a:rPr>
-              <a:t>[8] Vinten-Johansen P et al. Cholera, Chloroform, and the Science of Medicine: A Life of John Snow. OUP, 2003.</a:t>
-            </a:r>
-            <a:endParaRPr lang="en-US" sz="900" dirty="0"/>
-          </a:p>
-          <a:p>
-            <a:pPr marL="0" indent="0">
-              <a:spcAft>
-                <a:spcPts val="400"/>
-              </a:spcAft>
-              <a:buNone/>
-            </a:pPr>
-            <a:r>
-              <a:rPr lang="en-US" sz="900" dirty="0">
-                <a:solidFill>
-                  <a:srgbClr val="11121A"/>
-                </a:solidFill>
-                <a:latin typeface="Palatino Linotype" pitchFamily="34" charset="0"/>
-                <a:ea typeface="Palatino Linotype" pitchFamily="34" charset="-122"/>
-                <a:cs typeface="Palatino Linotype" pitchFamily="34" charset="-120"/>
-              </a:rPr>
-              <a:t>[9] Whitehead H. The Broad Street Pump. Macmillan’s Magazine, dec. 1865;13:113–122.</a:t>
-            </a:r>
-            <a:endParaRPr lang="en-US" sz="900" dirty="0"/>
-          </a:p>
-          <a:p>
-            <a:pPr marL="0" indent="0">
-              <a:spcAft>
-                <a:spcPts val="400"/>
-              </a:spcAft>
-              <a:buNone/>
-            </a:pPr>
-            <a:r>
-              <a:rPr lang="en-US" sz="900" dirty="0">
-                <a:solidFill>
-                  <a:srgbClr val="11121A"/>
-                </a:solidFill>
-                <a:latin typeface="Palatino Linotype" pitchFamily="34" charset="0"/>
-                <a:ea typeface="Palatino Linotype" pitchFamily="34" charset="-122"/>
-                <a:cs typeface="Palatino Linotype" pitchFamily="34" charset="-120"/>
-              </a:rPr>
-              <a:t>[10] Cameron D, Jones IG. Int J Epidemiol. 1983;12(4):393–396. DOI: 10.1093/ije/12.4.393</a:t>
-            </a:r>
-            <a:endParaRPr lang="en-US" sz="900" dirty="0"/>
-          </a:p>
-          <a:p>
-            <a:pPr marL="0" indent="0">
-              <a:spcAft>
-                <a:spcPts val="400"/>
-              </a:spcAft>
-              <a:buNone/>
-            </a:pPr>
-            <a:r>
-              <a:rPr lang="en-US" sz="900" dirty="0">
-                <a:solidFill>
-                  <a:srgbClr val="11121A"/>
-                </a:solidFill>
-                <a:latin typeface="Palatino Linotype" pitchFamily="34" charset="0"/>
-                <a:ea typeface="Palatino Linotype" pitchFamily="34" charset="-122"/>
-                <a:cs typeface="Palatino Linotype" pitchFamily="34" charset="-120"/>
-              </a:rPr>
-              <a:t>[11] Eyler JM. Soz Praventivmed. 2001;46(4):225–232. DOI: 10.1007/BF01593177</a:t>
-            </a:r>
-            <a:endParaRPr lang="en-US" sz="900" dirty="0"/>
-          </a:p>
-          <a:p>
-            <a:pPr marL="0" indent="0">
-              <a:spcAft>
-                <a:spcPts val="400"/>
-              </a:spcAft>
-              <a:buNone/>
-            </a:pPr>
-            <a:r>
-              <a:rPr lang="en-US" sz="900" dirty="0">
-                <a:solidFill>
-                  <a:srgbClr val="11121A"/>
-                </a:solidFill>
-                <a:latin typeface="Palatino Linotype" pitchFamily="34" charset="0"/>
-                <a:ea typeface="Palatino Linotype" pitchFamily="34" charset="-122"/>
-                <a:cs typeface="Palatino Linotype" pitchFamily="34" charset="-120"/>
-              </a:rPr>
-              <a:t>[12] Chave SPW. Med Hist. 1958;2(2):92–108. DOI: 10.1017/s0025727300023504</a:t>
-            </a:r>
-            <a:endParaRPr lang="en-US" sz="900" dirty="0"/>
-          </a:p>
-          <a:p>
-            <a:pPr marL="0" indent="0">
-              <a:spcAft>
-                <a:spcPts val="400"/>
-              </a:spcAft>
-              <a:buNone/>
-            </a:pPr>
-            <a:r>
-              <a:rPr lang="en-US" sz="900" dirty="0">
-                <a:solidFill>
-                  <a:srgbClr val="11121A"/>
-                </a:solidFill>
-                <a:latin typeface="Palatino Linotype" pitchFamily="34" charset="0"/>
-                <a:ea typeface="Palatino Linotype" pitchFamily="34" charset="-122"/>
-                <a:cs typeface="Palatino Linotype" pitchFamily="34" charset="-120"/>
-              </a:rPr>
-              <a:t>[13] Ramsay MAE. Proc (Bayl Univ Med Cent). 2006;19(1):24–28.</a:t>
-            </a:r>
-            <a:endParaRPr lang="en-US" sz="900" dirty="0"/>
-          </a:p>
-          <a:p>
-            <a:pPr marL="0" indent="0">
-              <a:spcAft>
-                <a:spcPts val="400"/>
-              </a:spcAft>
-              <a:buNone/>
-            </a:pPr>
-            <a:r>
-              <a:rPr lang="en-US" sz="900" dirty="0">
-                <a:solidFill>
-                  <a:srgbClr val="11121A"/>
-                </a:solidFill>
-                <a:latin typeface="Palatino Linotype" pitchFamily="34" charset="0"/>
-                <a:ea typeface="Palatino Linotype" pitchFamily="34" charset="-122"/>
-                <a:cs typeface="Palatino Linotype" pitchFamily="34" charset="-120"/>
-              </a:rPr>
-              <a:t>[14] Lippi D, Gotuzzo E. Clin Microbiol Infect. 2014;20(3):191–195.</a:t>
-            </a:r>
-            <a:endParaRPr lang="en-US" sz="900" dirty="0"/>
-          </a:p>
-        </p:txBody>
-      </p:sp>
-      <p:sp>
-        <p:nvSpPr>
-          <p:cNvPr id="8" name="Shape 6"/>
-          <p:cNvSpPr/>
-          <p:nvPr/>
-        </p:nvSpPr>
-        <p:spPr>
-          <a:xfrm>
-            <a:off x="6217920" y="2057400"/>
-            <a:ext cx="5349240" cy="3931920"/>
-          </a:xfrm>
-          <a:prstGeom prst="roundRect">
-            <a:avLst>
-              <a:gd name="adj" fmla="val 2093"/>
-            </a:avLst>
-          </a:prstGeom>
-          <a:solidFill>
-            <a:srgbClr val="ECEAE4"/>
-          </a:solidFill>
-          <a:ln w="12700">
-            <a:solidFill>
-              <a:srgbClr val="ECEAE4"/>
-            </a:solidFill>
-            <a:prstDash val="solid"/>
-          </a:ln>
-        </p:spPr>
-        <p:txBody>
-          <a:bodyPr/>
-          <a:lstStyle/>
-          <a:p>
-            <a:endParaRPr lang="ro-RO"/>
-          </a:p>
-        </p:txBody>
-      </p:sp>
-      <p:sp>
-        <p:nvSpPr>
-          <p:cNvPr id="9" name="Text 7"/>
-          <p:cNvSpPr/>
-          <p:nvPr/>
-        </p:nvSpPr>
-        <p:spPr>
-          <a:xfrm>
-            <a:off x="6537960" y="2194560"/>
-            <a:ext cx="4709160" cy="292608"/>
-          </a:xfrm>
-          <a:prstGeom prst="rect">
-            <a:avLst/>
-          </a:prstGeom>
-          <a:noFill/>
-          <a:ln/>
-        </p:spPr>
-        <p:txBody>
-          <a:bodyPr wrap="square" lIns="0" tIns="0" rIns="0" bIns="0" rtlCol="0" anchor="ctr"/>
-          <a:lstStyle/>
-          <a:p>
-            <a:pPr marL="0" indent="0">
-              <a:buNone/>
-            </a:pPr>
-            <a:r>
-              <a:rPr lang="en-US" sz="1350" b="1" dirty="0">
-                <a:solidFill>
-                  <a:srgbClr val="0E7C6B"/>
-                </a:solidFill>
-                <a:latin typeface="Palatino Linotype" pitchFamily="34" charset="0"/>
-                <a:ea typeface="Palatino Linotype" pitchFamily="34" charset="-122"/>
-                <a:cs typeface="Palatino Linotype" pitchFamily="34" charset="-120"/>
-              </a:rPr>
-              <a:t>Modern — focare, formare, genomică</a:t>
-            </a:r>
-            <a:endParaRPr lang="en-US" sz="1350" dirty="0"/>
-          </a:p>
-        </p:txBody>
-      </p:sp>
-      <p:sp>
-        <p:nvSpPr>
-          <p:cNvPr id="10" name="Text 8"/>
-          <p:cNvSpPr/>
-          <p:nvPr/>
-        </p:nvSpPr>
-        <p:spPr>
-          <a:xfrm>
-            <a:off x="6675120" y="2560320"/>
-            <a:ext cx="4663440" cy="3291840"/>
-          </a:xfrm>
-          <a:prstGeom prst="rect">
-            <a:avLst/>
-          </a:prstGeom>
-          <a:noFill/>
-          <a:ln/>
-        </p:spPr>
-        <p:txBody>
-          <a:bodyPr wrap="square" lIns="0" tIns="0" rIns="0" bIns="0" rtlCol="0" anchor="t"/>
-          <a:lstStyle/>
-          <a:p>
-            <a:pPr marL="0" indent="0">
-              <a:spcAft>
-                <a:spcPts val="400"/>
-              </a:spcAft>
-              <a:buNone/>
-            </a:pPr>
-            <a:r>
-              <a:rPr lang="en-US" sz="900" dirty="0">
-                <a:solidFill>
-                  <a:srgbClr val="11121A"/>
-                </a:solidFill>
-                <a:latin typeface="Palatino Linotype" pitchFamily="34" charset="0"/>
-                <a:ea typeface="Palatino Linotype" pitchFamily="34" charset="-122"/>
-                <a:cs typeface="Palatino Linotype" pitchFamily="34" charset="-120"/>
-              </a:rPr>
-              <a:t>[15] CDC. MMWR. 1993;42(14):258–263.</a:t>
-            </a:r>
-            <a:endParaRPr lang="en-US" sz="900" dirty="0"/>
-          </a:p>
-          <a:p>
-            <a:pPr marL="0" indent="0">
-              <a:spcAft>
-                <a:spcPts val="400"/>
-              </a:spcAft>
-              <a:buNone/>
-            </a:pPr>
-            <a:r>
-              <a:rPr lang="en-US" sz="900" dirty="0">
-                <a:solidFill>
-                  <a:srgbClr val="11121A"/>
-                </a:solidFill>
-                <a:latin typeface="Palatino Linotype" pitchFamily="34" charset="0"/>
-                <a:ea typeface="Palatino Linotype" pitchFamily="34" charset="-122"/>
-                <a:cs typeface="Palatino Linotype" pitchFamily="34" charset="-120"/>
-              </a:rPr>
-              <a:t>[16] Bell BP et al. JAMA. 1994;272(17):1349–1353. DOI: 10.1001/jama.1994.03520170059036</a:t>
-            </a:r>
-            <a:endParaRPr lang="en-US" sz="900" dirty="0"/>
-          </a:p>
-          <a:p>
-            <a:pPr marL="0" indent="0">
-              <a:spcAft>
-                <a:spcPts val="400"/>
-              </a:spcAft>
-              <a:buNone/>
-            </a:pPr>
-            <a:r>
-              <a:rPr lang="en-US" sz="900" dirty="0">
-                <a:solidFill>
-                  <a:srgbClr val="11121A"/>
-                </a:solidFill>
-                <a:latin typeface="Palatino Linotype" pitchFamily="34" charset="0"/>
-                <a:ea typeface="Palatino Linotype" pitchFamily="34" charset="-122"/>
-                <a:cs typeface="Palatino Linotype" pitchFamily="34" charset="-120"/>
-              </a:rPr>
-              <a:t>[17] Tuttle J et al. Epidemiol Infect. 1999;122(2):185–192. DOI: 10.1017/s0950268898001976</a:t>
-            </a:r>
-            <a:endParaRPr lang="en-US" sz="900" dirty="0"/>
-          </a:p>
-          <a:p>
-            <a:pPr marL="0" indent="0">
-              <a:spcAft>
-                <a:spcPts val="400"/>
-              </a:spcAft>
-              <a:buNone/>
-            </a:pPr>
-            <a:r>
-              <a:rPr lang="en-US" sz="900" dirty="0">
-                <a:solidFill>
-                  <a:srgbClr val="11121A"/>
-                </a:solidFill>
-                <a:latin typeface="Palatino Linotype" pitchFamily="34" charset="0"/>
-                <a:ea typeface="Palatino Linotype" pitchFamily="34" charset="-122"/>
-                <a:cs typeface="Palatino Linotype" pitchFamily="34" charset="-120"/>
-              </a:rPr>
-              <a:t>[18] Baize S et al. N Engl J Med. 2014;371(15):1418–1425. DOI: 10.1056/NEJMoa1404505</a:t>
-            </a:r>
-            <a:endParaRPr lang="en-US" sz="900" dirty="0"/>
-          </a:p>
-          <a:p>
-            <a:pPr marL="0" indent="0">
-              <a:spcAft>
-                <a:spcPts val="400"/>
-              </a:spcAft>
-              <a:buNone/>
-            </a:pPr>
-            <a:r>
-              <a:rPr lang="en-US" sz="900" dirty="0">
-                <a:solidFill>
-                  <a:srgbClr val="11121A"/>
-                </a:solidFill>
-                <a:latin typeface="Palatino Linotype" pitchFamily="34" charset="0"/>
-                <a:ea typeface="Palatino Linotype" pitchFamily="34" charset="-122"/>
-                <a:cs typeface="Palatino Linotype" pitchFamily="34" charset="-120"/>
-              </a:rPr>
-              <a:t>[19] Devault AM et al. N Engl J Med. 2014;370(4):334–340. DOI: 10.1056/NEJMoa1308663</a:t>
-            </a:r>
-            <a:endParaRPr lang="en-US" sz="900" dirty="0"/>
-          </a:p>
-          <a:p>
-            <a:pPr marL="0" indent="0">
-              <a:spcAft>
-                <a:spcPts val="400"/>
-              </a:spcAft>
-              <a:buNone/>
-            </a:pPr>
-            <a:r>
-              <a:rPr lang="en-US" sz="900" dirty="0">
-                <a:solidFill>
-                  <a:srgbClr val="11121A"/>
-                </a:solidFill>
-                <a:latin typeface="Palatino Linotype" pitchFamily="34" charset="0"/>
-                <a:ea typeface="Palatino Linotype" pitchFamily="34" charset="-122"/>
-                <a:cs typeface="Palatino Linotype" pitchFamily="34" charset="-120"/>
-              </a:rPr>
-              <a:t>[20] Dorman MJ et al. Proc Biol Sci. 2019;286(1900):20182025. DOI: 10.1098/rspb.2018.2025</a:t>
-            </a:r>
-            <a:endParaRPr lang="en-US" sz="900" dirty="0"/>
-          </a:p>
-          <a:p>
-            <a:pPr marL="0" indent="0">
-              <a:spcAft>
-                <a:spcPts val="400"/>
-              </a:spcAft>
-              <a:buNone/>
-            </a:pPr>
-            <a:r>
-              <a:rPr lang="en-US" sz="900" dirty="0">
-                <a:solidFill>
-                  <a:srgbClr val="11121A"/>
-                </a:solidFill>
-                <a:latin typeface="Palatino Linotype" pitchFamily="34" charset="0"/>
-                <a:ea typeface="Palatino Linotype" pitchFamily="34" charset="-122"/>
-                <a:cs typeface="Palatino Linotype" pitchFamily="34" charset="-120"/>
-              </a:rPr>
-              <a:t>[21] CDC. Principles of Epidemiology, ed. 3, Lecția 6. Rev. 2011.</a:t>
-            </a:r>
-            <a:endParaRPr lang="en-US" sz="900" dirty="0"/>
-          </a:p>
-          <a:p>
-            <a:pPr marL="0" indent="0">
-              <a:spcAft>
-                <a:spcPts val="400"/>
-              </a:spcAft>
-              <a:buNone/>
-            </a:pPr>
-            <a:r>
-              <a:rPr lang="en-US" sz="900" dirty="0">
-                <a:solidFill>
-                  <a:srgbClr val="11121A"/>
-                </a:solidFill>
-                <a:latin typeface="Palatino Linotype" pitchFamily="34" charset="0"/>
-                <a:ea typeface="Palatino Linotype" pitchFamily="34" charset="-122"/>
-                <a:cs typeface="Palatino Linotype" pitchFamily="34" charset="-120"/>
-              </a:rPr>
-              <a:t>[22] FEM Wiki (găzduit de ECDC), export PDF, 417 p., creat la 29.11.2022.</a:t>
-            </a:r>
-            <a:endParaRPr lang="en-US" sz="900" dirty="0"/>
-          </a:p>
-          <a:p>
-            <a:pPr marL="0" indent="0">
-              <a:spcAft>
-                <a:spcPts val="400"/>
-              </a:spcAft>
-              <a:buNone/>
-            </a:pPr>
-            <a:r>
-              <a:rPr lang="en-US" sz="900" dirty="0">
-                <a:solidFill>
-                  <a:srgbClr val="11121A"/>
-                </a:solidFill>
-                <a:latin typeface="Palatino Linotype" pitchFamily="34" charset="0"/>
-                <a:ea typeface="Palatino Linotype" pitchFamily="34" charset="-122"/>
-                <a:cs typeface="Palatino Linotype" pitchFamily="34" charset="-120"/>
-              </a:rPr>
-              <a:t>[23] Gregg MB (ed.). Field Epidemiology, ed. 3. OUP, 2008. ISBN 9780195313802.</a:t>
-            </a:r>
-            <a:endParaRPr lang="en-US" sz="900" dirty="0"/>
-          </a:p>
-          <a:p>
-            <a:pPr marL="0" indent="0">
-              <a:spcAft>
-                <a:spcPts val="400"/>
-              </a:spcAft>
-              <a:buNone/>
-            </a:pPr>
-            <a:r>
-              <a:rPr lang="en-US" sz="900" dirty="0">
-                <a:solidFill>
-                  <a:srgbClr val="11121A"/>
-                </a:solidFill>
-                <a:latin typeface="Palatino Linotype" pitchFamily="34" charset="0"/>
-                <a:ea typeface="Palatino Linotype" pitchFamily="34" charset="-122"/>
-                <a:cs typeface="Palatino Linotype" pitchFamily="34" charset="-120"/>
-              </a:rPr>
-              <a:t>[24] Gigerenzer G, Hoffrage U. Psychol Rev. 1995;102(4):684–704. DOI: 10.1037/0033-295X.102.4.684</a:t>
-            </a:r>
-            <a:endParaRPr lang="en-US" sz="900" dirty="0"/>
-          </a:p>
-          <a:p>
-            <a:pPr marL="0" indent="0">
-              <a:spcAft>
-                <a:spcPts val="400"/>
-              </a:spcAft>
-              <a:buNone/>
-            </a:pPr>
-            <a:r>
-              <a:rPr lang="en-US" sz="900" dirty="0">
-                <a:solidFill>
-                  <a:srgbClr val="11121A"/>
-                </a:solidFill>
-                <a:latin typeface="Palatino Linotype" pitchFamily="34" charset="0"/>
-                <a:ea typeface="Palatino Linotype" pitchFamily="34" charset="-122"/>
-                <a:cs typeface="Palatino Linotype" pitchFamily="34" charset="-120"/>
-              </a:rPr>
-              <a:t>[25] INSP–CNSCBT. Raport pentru anul 2024 (15 oct. 2025, 84 p.).</a:t>
-            </a:r>
-            <a:endParaRPr lang="en-US" sz="900" dirty="0"/>
-          </a:p>
-          <a:p>
-            <a:pPr marL="0" indent="0">
-              <a:spcAft>
-                <a:spcPts val="400"/>
-              </a:spcAft>
-              <a:buNone/>
-            </a:pPr>
-            <a:r>
-              <a:rPr lang="en-US" sz="900" dirty="0">
-                <a:solidFill>
-                  <a:srgbClr val="11121A"/>
-                </a:solidFill>
-                <a:latin typeface="Palatino Linotype" pitchFamily="34" charset="0"/>
-                <a:ea typeface="Palatino Linotype" pitchFamily="34" charset="-122"/>
-                <a:cs typeface="Palatino Linotype" pitchFamily="34" charset="-120"/>
-              </a:rPr>
-              <a:t>[26] OMS. Wkly Epidemiol Rec. 2026;101(35) și 101(38): holera, 2025–2026.</a:t>
-            </a:r>
-            <a:endParaRPr lang="en-US" sz="900" dirty="0"/>
-          </a:p>
-          <a:p>
-            <a:pPr marL="0" indent="0">
-              <a:spcAft>
-                <a:spcPts val="400"/>
-              </a:spcAft>
-              <a:buNone/>
-            </a:pPr>
-            <a:r>
-              <a:rPr lang="en-US" sz="900" dirty="0">
-                <a:solidFill>
-                  <a:srgbClr val="11121A"/>
-                </a:solidFill>
-                <a:latin typeface="Palatino Linotype" pitchFamily="34" charset="0"/>
-                <a:ea typeface="Palatino Linotype" pitchFamily="34" charset="-122"/>
-                <a:cs typeface="Palatino Linotype" pitchFamily="34" charset="-120"/>
-              </a:rPr>
-              <a:t>[27] OMS. Tabelul SARS (2003); Ebola 2014–2016; Origins of the 2014 Ebola epidemic (2015).</a:t>
-            </a:r>
-            <a:endParaRPr lang="en-US" sz="900" dirty="0"/>
-          </a:p>
-          <a:p>
-            <a:pPr marL="0" indent="0">
-              <a:spcAft>
-                <a:spcPts val="400"/>
-              </a:spcAft>
-              <a:buNone/>
-            </a:pPr>
-            <a:r>
-              <a:rPr lang="en-US" sz="900" dirty="0">
-                <a:solidFill>
-                  <a:srgbClr val="11121A"/>
-                </a:solidFill>
-                <a:latin typeface="Palatino Linotype" pitchFamily="34" charset="0"/>
-                <a:ea typeface="Palatino Linotype" pitchFamily="34" charset="-122"/>
-                <a:cs typeface="Palatino Linotype" pitchFamily="34" charset="-120"/>
-              </a:rPr>
-              <a:t>[28] CDC. About EIS; EIS 2025 annual update. ECDC. Siturile de formare (6.02.2026). TEPHINET.</a:t>
-            </a:r>
-            <a:endParaRPr lang="en-US" sz="900" dirty="0"/>
-          </a:p>
-          <a:p>
-            <a:pPr marL="0" indent="0">
-              <a:spcAft>
-                <a:spcPts val="400"/>
-              </a:spcAft>
-              <a:buNone/>
-            </a:pPr>
-            <a:r>
-              <a:rPr lang="en-US" sz="900" dirty="0">
-                <a:solidFill>
-                  <a:srgbClr val="11121A"/>
-                </a:solidFill>
-                <a:latin typeface="Palatino Linotype" pitchFamily="34" charset="0"/>
-                <a:ea typeface="Palatino Linotype" pitchFamily="34" charset="-122"/>
-                <a:cs typeface="Palatino Linotype" pitchFamily="34" charset="-120"/>
-              </a:rPr>
-              <a:t>[29] INS. TEMPO POP105A și SAN104A. Eurostat. hlth_rs_spec; hlth_rs_physcat.</a:t>
-            </a:r>
-            <a:endParaRPr lang="en-US" sz="900" dirty="0"/>
-          </a:p>
-          <a:p>
-            <a:pPr marL="0" indent="0">
-              <a:spcAft>
-                <a:spcPts val="400"/>
-              </a:spcAft>
-              <a:buNone/>
-            </a:pPr>
-            <a:r>
-              <a:rPr lang="en-US" sz="900" dirty="0">
-                <a:solidFill>
-                  <a:srgbClr val="11121A"/>
-                </a:solidFill>
-                <a:latin typeface="Palatino Linotype" pitchFamily="34" charset="0"/>
-                <a:ea typeface="Palatino Linotype" pitchFamily="34" charset="-122"/>
-                <a:cs typeface="Palatino Linotype" pitchFamily="34" charset="-120"/>
-              </a:rPr>
-              <a:t>[30] Directiva (UE) 2024/3019 (apele uzate urbane), art. 17.</a:t>
-            </a:r>
-            <a:endParaRPr lang="en-US" sz="900" dirty="0"/>
-          </a:p>
-        </p:txBody>
-      </p:sp>
-      <p:sp>
-        <p:nvSpPr>
-          <p:cNvPr id="11" name="Text 9"/>
-          <p:cNvSpPr/>
-          <p:nvPr/>
-        </p:nvSpPr>
-        <p:spPr>
-          <a:xfrm>
-            <a:off x="594360" y="6309360"/>
-            <a:ext cx="10972800" cy="310896"/>
-          </a:xfrm>
-          <a:prstGeom prst="rect">
-            <a:avLst/>
-          </a:prstGeom>
-          <a:noFill/>
-          <a:ln/>
-        </p:spPr>
-        <p:txBody>
-          <a:bodyPr wrap="square" lIns="0" tIns="0" rIns="0" bIns="0" rtlCol="0" anchor="ctr"/>
-          <a:lstStyle/>
-          <a:p>
-            <a:pPr marL="0" indent="0">
-              <a:buNone/>
-            </a:pPr>
-            <a:r>
-              <a:rPr lang="en-US" sz="900" i="1" dirty="0">
-                <a:solidFill>
-                  <a:srgbClr val="585A64"/>
-                </a:solidFill>
-                <a:latin typeface="Palatino Linotype" pitchFamily="34" charset="0"/>
-                <a:ea typeface="Palatino Linotype" pitchFamily="34" charset="-122"/>
-                <a:cs typeface="Palatino Linotype" pitchFamily="34" charset="-120"/>
-              </a:rPr>
-              <a:t>Ce nu s-a putut verifica este listat în caseta „Ce nu putem afirma” din notele de curs. Constatările administrative privind fișa disciplinei sunt într-o notă separată, adresată titularului.</a:t>
-            </a:r>
-            <a:endParaRPr lang="en-US" sz="900" dirty="0"/>
-          </a:p>
-        </p:txBody>
-      </p:sp>
-    </p:spTree>
-  </p:cSld>
-  <p:clrMapOvr>
-    <a:masterClrMapping/>
-  </p:clrMapOvr>
-</p:sld>
-</file>
-
-<file path=ppt/slides/slide52.xml><?xml version="1.0" encoding="utf-8"?>
 <p:sld xmlns:a="http://schemas.openxmlformats.org/drawingml/2006/main" xmlns:r="http://schemas.openxmlformats.org/officeDocument/2006/relationships" xmlns:p="http://schemas.openxmlformats.org/presentationml/2006/main">
   <p:cSld name="Slide 51">
     <p:bg>

</xml_diff>